<commit_message>
Corrige le README, met à jour le notebook et le support, retire les fichiers parasites
</commit_message>
<xml_diff>
--- a/Elices-Diez_Josy_3_Support_presentation_062026.pptx
+++ b/Elices-Diez_Josy_3_Support_presentation_062026.pptx
@@ -5,28 +5,28 @@
     <p:sldMasterId id="2147483648" r:id="rId1"/>
   </p:sldMasterIdLst>
   <p:sldIdLst>
-    <p:sldId id="256" r:id="rId7"/>
-    <p:sldId id="257" r:id="rId8"/>
-    <p:sldId id="258" r:id="rId9"/>
-    <p:sldId id="259" r:id="rId10"/>
-    <p:sldId id="260" r:id="rId11"/>
-    <p:sldId id="261" r:id="rId12"/>
-    <p:sldId id="262" r:id="rId13"/>
-    <p:sldId id="263" r:id="rId14"/>
-    <p:sldId id="264" r:id="rId15"/>
-    <p:sldId id="265" r:id="rId16"/>
-    <p:sldId id="266" r:id="rId17"/>
-    <p:sldId id="267" r:id="rId18"/>
-    <p:sldId id="268" r:id="rId19"/>
-    <p:sldId id="269" r:id="rId20"/>
-    <p:sldId id="270" r:id="rId21"/>
-    <p:sldId id="271" r:id="rId22"/>
-    <p:sldId id="272" r:id="rId23"/>
-    <p:sldId id="273" r:id="rId24"/>
-    <p:sldId id="274" r:id="rId25"/>
-    <p:sldId id="275" r:id="rId26"/>
+    <p:sldId id="256" r:id="rId2"/>
+    <p:sldId id="257" r:id="rId3"/>
+    <p:sldId id="258" r:id="rId4"/>
+    <p:sldId id="259" r:id="rId5"/>
+    <p:sldId id="260" r:id="rId6"/>
+    <p:sldId id="261" r:id="rId7"/>
+    <p:sldId id="262" r:id="rId8"/>
+    <p:sldId id="263" r:id="rId9"/>
+    <p:sldId id="264" r:id="rId10"/>
+    <p:sldId id="265" r:id="rId11"/>
+    <p:sldId id="266" r:id="rId12"/>
+    <p:sldId id="267" r:id="rId13"/>
+    <p:sldId id="268" r:id="rId14"/>
+    <p:sldId id="269" r:id="rId15"/>
+    <p:sldId id="270" r:id="rId16"/>
+    <p:sldId id="271" r:id="rId17"/>
+    <p:sldId id="272" r:id="rId18"/>
+    <p:sldId id="273" r:id="rId19"/>
+    <p:sldId id="274" r:id="rId20"/>
+    <p:sldId id="275" r:id="rId21"/>
   </p:sldIdLst>
-  <p:sldSz cx="12193200" cy="6858000" type="screen4x3"/>
+  <p:sldSz cx="12193588" cy="6858000"/>
   <p:notesSz cx="6858000" cy="9144000"/>
   <p:defaultTextStyle>
     <a:defPPr>
@@ -123,6 +123,22 @@
       </a:defRPr>
     </a:lvl9pPr>
   </p:defaultTextStyle>
+  <p:extLst>
+    <p:ext uri="{EFAFB233-063F-42B5-8137-9DF3F51BA10A}">
+      <p15:sldGuideLst xmlns:p15="http://schemas.microsoft.com/office/powerpoint/2012/main">
+        <p15:guide id="1" orient="horz" pos="2160">
+          <p15:clr>
+            <a:srgbClr val="A4A3A4"/>
+          </p15:clr>
+        </p15:guide>
+        <p15:guide id="2" pos="2880">
+          <p15:clr>
+            <a:srgbClr val="A4A3A4"/>
+          </p15:clr>
+        </p15:guide>
+      </p15:sldGuideLst>
+    </p:ext>
+  </p:extLst>
 </p:presentation>
 </file>
 
@@ -164,10 +180,9 @@
           <a:lstStyle/>
           <a:p>
             <a:r>
-              <a:rPr lang="en-US" smtClean="0"/>
+              <a:rPr lang="en-US"/>
               <a:t>Click to edit Master title style</a:t>
             </a:r>
-            <a:endParaRPr lang="en-US"/>
           </a:p>
         </p:txBody>
       </p:sp>
@@ -283,10 +298,9 @@
           </a:lstStyle>
           <a:p>
             <a:r>
-              <a:rPr lang="en-US" smtClean="0"/>
+              <a:rPr lang="en-US"/>
               <a:t>Click to edit Master subtitle style</a:t>
             </a:r>
-            <a:endParaRPr lang="en-US"/>
           </a:p>
         </p:txBody>
       </p:sp>
@@ -307,7 +321,7 @@
           <a:p>
             <a:fld id="{5BCAD085-E8A6-8845-BD4E-CB4CCA059FC4}" type="datetimeFigureOut">
               <a:rPr lang="en-US" smtClean="0"/>
-              <a:t>1/27/13</a:t>
+              <a:t>7/20/2026</a:t>
             </a:fld>
             <a:endParaRPr lang="en-US"/>
           </a:p>
@@ -349,7 +363,7 @@
           <a:p>
             <a:fld id="{C1FF6DA9-008F-8B48-92A6-B652298478BF}" type="slidenum">
               <a:rPr lang="en-US" smtClean="0"/>
-              <a:t>‹#›</a:t>
+              <a:t>‹N°›</a:t>
             </a:fld>
             <a:endParaRPr lang="en-US"/>
           </a:p>
@@ -401,10 +415,9 @@
           <a:lstStyle/>
           <a:p>
             <a:r>
-              <a:rPr lang="en-US" smtClean="0"/>
+              <a:rPr lang="en-US"/>
               <a:t>Click to edit Master title style</a:t>
             </a:r>
-            <a:endParaRPr lang="en-US"/>
           </a:p>
         </p:txBody>
       </p:sp>
@@ -425,38 +438,37 @@
           <a:p>
             <a:pPr lvl="0"/>
             <a:r>
-              <a:rPr lang="en-US" smtClean="0"/>
+              <a:rPr lang="en-US"/>
               <a:t>Click to edit Master text styles</a:t>
             </a:r>
           </a:p>
           <a:p>
             <a:pPr lvl="1"/>
             <a:r>
-              <a:rPr lang="en-US" smtClean="0"/>
+              <a:rPr lang="en-US"/>
               <a:t>Second level</a:t>
             </a:r>
           </a:p>
           <a:p>
             <a:pPr lvl="2"/>
             <a:r>
-              <a:rPr lang="en-US" smtClean="0"/>
+              <a:rPr lang="en-US"/>
               <a:t>Third level</a:t>
             </a:r>
           </a:p>
           <a:p>
             <a:pPr lvl="3"/>
             <a:r>
-              <a:rPr lang="en-US" smtClean="0"/>
+              <a:rPr lang="en-US"/>
               <a:t>Fourth level</a:t>
             </a:r>
           </a:p>
           <a:p>
             <a:pPr lvl="4"/>
             <a:r>
-              <a:rPr lang="en-US" smtClean="0"/>
+              <a:rPr lang="en-US"/>
               <a:t>Fifth level</a:t>
             </a:r>
-            <a:endParaRPr lang="en-US"/>
           </a:p>
         </p:txBody>
       </p:sp>
@@ -477,7 +489,7 @@
           <a:p>
             <a:fld id="{5BCAD085-E8A6-8845-BD4E-CB4CCA059FC4}" type="datetimeFigureOut">
               <a:rPr lang="en-US" smtClean="0"/>
-              <a:t>1/27/13</a:t>
+              <a:t>7/20/2026</a:t>
             </a:fld>
             <a:endParaRPr lang="en-US"/>
           </a:p>
@@ -519,7 +531,7 @@
           <a:p>
             <a:fld id="{C1FF6DA9-008F-8B48-92A6-B652298478BF}" type="slidenum">
               <a:rPr lang="en-US" smtClean="0"/>
-              <a:t>‹#›</a:t>
+              <a:t>‹N°›</a:t>
             </a:fld>
             <a:endParaRPr lang="en-US"/>
           </a:p>
@@ -576,10 +588,9 @@
           <a:lstStyle/>
           <a:p>
             <a:r>
-              <a:rPr lang="en-US" smtClean="0"/>
+              <a:rPr lang="en-US"/>
               <a:t>Click to edit Master title style</a:t>
             </a:r>
-            <a:endParaRPr lang="en-US"/>
           </a:p>
         </p:txBody>
       </p:sp>
@@ -605,38 +616,37 @@
           <a:p>
             <a:pPr lvl="0"/>
             <a:r>
-              <a:rPr lang="en-US" smtClean="0"/>
+              <a:rPr lang="en-US"/>
               <a:t>Click to edit Master text styles</a:t>
             </a:r>
           </a:p>
           <a:p>
             <a:pPr lvl="1"/>
             <a:r>
-              <a:rPr lang="en-US" smtClean="0"/>
+              <a:rPr lang="en-US"/>
               <a:t>Second level</a:t>
             </a:r>
           </a:p>
           <a:p>
             <a:pPr lvl="2"/>
             <a:r>
-              <a:rPr lang="en-US" smtClean="0"/>
+              <a:rPr lang="en-US"/>
               <a:t>Third level</a:t>
             </a:r>
           </a:p>
           <a:p>
             <a:pPr lvl="3"/>
             <a:r>
-              <a:rPr lang="en-US" smtClean="0"/>
+              <a:rPr lang="en-US"/>
               <a:t>Fourth level</a:t>
             </a:r>
           </a:p>
           <a:p>
             <a:pPr lvl="4"/>
             <a:r>
-              <a:rPr lang="en-US" smtClean="0"/>
+              <a:rPr lang="en-US"/>
               <a:t>Fifth level</a:t>
             </a:r>
-            <a:endParaRPr lang="en-US"/>
           </a:p>
         </p:txBody>
       </p:sp>
@@ -657,7 +667,7 @@
           <a:p>
             <a:fld id="{5BCAD085-E8A6-8845-BD4E-CB4CCA059FC4}" type="datetimeFigureOut">
               <a:rPr lang="en-US" smtClean="0"/>
-              <a:t>1/27/13</a:t>
+              <a:t>7/20/2026</a:t>
             </a:fld>
             <a:endParaRPr lang="en-US"/>
           </a:p>
@@ -699,7 +709,7 @@
           <a:p>
             <a:fld id="{C1FF6DA9-008F-8B48-92A6-B652298478BF}" type="slidenum">
               <a:rPr lang="en-US" smtClean="0"/>
-              <a:t>‹#›</a:t>
+              <a:t>‹N°›</a:t>
             </a:fld>
             <a:endParaRPr lang="en-US"/>
           </a:p>
@@ -751,10 +761,9 @@
           <a:lstStyle/>
           <a:p>
             <a:r>
-              <a:rPr lang="en-US" smtClean="0"/>
+              <a:rPr lang="en-US"/>
               <a:t>Click to edit Master title style</a:t>
             </a:r>
-            <a:endParaRPr lang="en-US"/>
           </a:p>
         </p:txBody>
       </p:sp>
@@ -775,38 +784,37 @@
           <a:p>
             <a:pPr lvl="0"/>
             <a:r>
-              <a:rPr lang="en-US" smtClean="0"/>
+              <a:rPr lang="en-US"/>
               <a:t>Click to edit Master text styles</a:t>
             </a:r>
           </a:p>
           <a:p>
             <a:pPr lvl="1"/>
             <a:r>
-              <a:rPr lang="en-US" smtClean="0"/>
+              <a:rPr lang="en-US"/>
               <a:t>Second level</a:t>
             </a:r>
           </a:p>
           <a:p>
             <a:pPr lvl="2"/>
             <a:r>
-              <a:rPr lang="en-US" smtClean="0"/>
+              <a:rPr lang="en-US"/>
               <a:t>Third level</a:t>
             </a:r>
           </a:p>
           <a:p>
             <a:pPr lvl="3"/>
             <a:r>
-              <a:rPr lang="en-US" smtClean="0"/>
+              <a:rPr lang="en-US"/>
               <a:t>Fourth level</a:t>
             </a:r>
           </a:p>
           <a:p>
             <a:pPr lvl="4"/>
             <a:r>
-              <a:rPr lang="en-US" smtClean="0"/>
+              <a:rPr lang="en-US"/>
               <a:t>Fifth level</a:t>
             </a:r>
-            <a:endParaRPr lang="en-US"/>
           </a:p>
         </p:txBody>
       </p:sp>
@@ -827,7 +835,7 @@
           <a:p>
             <a:fld id="{5BCAD085-E8A6-8845-BD4E-CB4CCA059FC4}" type="datetimeFigureOut">
               <a:rPr lang="en-US" smtClean="0"/>
-              <a:t>1/27/13</a:t>
+              <a:t>7/20/2026</a:t>
             </a:fld>
             <a:endParaRPr lang="en-US"/>
           </a:p>
@@ -869,7 +877,7 @@
           <a:p>
             <a:fld id="{C1FF6DA9-008F-8B48-92A6-B652298478BF}" type="slidenum">
               <a:rPr lang="en-US" smtClean="0"/>
-              <a:t>‹#›</a:t>
+              <a:t>‹N°›</a:t>
             </a:fld>
             <a:endParaRPr lang="en-US"/>
           </a:p>
@@ -930,10 +938,9 @@
           </a:lstStyle>
           <a:p>
             <a:r>
-              <a:rPr lang="en-US" smtClean="0"/>
+              <a:rPr lang="en-US"/>
               <a:t>Click to edit Master title style</a:t>
             </a:r>
-            <a:endParaRPr lang="en-US"/>
           </a:p>
         </p:txBody>
       </p:sp>
@@ -1050,7 +1057,7 @@
           <a:p>
             <a:pPr lvl="0"/>
             <a:r>
-              <a:rPr lang="en-US" smtClean="0"/>
+              <a:rPr lang="en-US"/>
               <a:t>Click to edit Master text styles</a:t>
             </a:r>
           </a:p>
@@ -1073,7 +1080,7 @@
           <a:p>
             <a:fld id="{5BCAD085-E8A6-8845-BD4E-CB4CCA059FC4}" type="datetimeFigureOut">
               <a:rPr lang="en-US" smtClean="0"/>
-              <a:t>1/27/13</a:t>
+              <a:t>7/20/2026</a:t>
             </a:fld>
             <a:endParaRPr lang="en-US"/>
           </a:p>
@@ -1115,7 +1122,7 @@
           <a:p>
             <a:fld id="{C1FF6DA9-008F-8B48-92A6-B652298478BF}" type="slidenum">
               <a:rPr lang="en-US" smtClean="0"/>
-              <a:t>‹#›</a:t>
+              <a:t>‹N°›</a:t>
             </a:fld>
             <a:endParaRPr lang="en-US"/>
           </a:p>
@@ -1167,10 +1174,9 @@
           <a:lstStyle/>
           <a:p>
             <a:r>
-              <a:rPr lang="en-US" smtClean="0"/>
+              <a:rPr lang="en-US"/>
               <a:t>Click to edit Master title style</a:t>
             </a:r>
-            <a:endParaRPr lang="en-US"/>
           </a:p>
         </p:txBody>
       </p:sp>
@@ -1224,38 +1230,37 @@
           <a:p>
             <a:pPr lvl="0"/>
             <a:r>
-              <a:rPr lang="en-US" smtClean="0"/>
+              <a:rPr lang="en-US"/>
               <a:t>Click to edit Master text styles</a:t>
             </a:r>
           </a:p>
           <a:p>
             <a:pPr lvl="1"/>
             <a:r>
-              <a:rPr lang="en-US" smtClean="0"/>
+              <a:rPr lang="en-US"/>
               <a:t>Second level</a:t>
             </a:r>
           </a:p>
           <a:p>
             <a:pPr lvl="2"/>
             <a:r>
-              <a:rPr lang="en-US" smtClean="0"/>
+              <a:rPr lang="en-US"/>
               <a:t>Third level</a:t>
             </a:r>
           </a:p>
           <a:p>
             <a:pPr lvl="3"/>
             <a:r>
-              <a:rPr lang="en-US" smtClean="0"/>
+              <a:rPr lang="en-US"/>
               <a:t>Fourth level</a:t>
             </a:r>
           </a:p>
           <a:p>
             <a:pPr lvl="4"/>
             <a:r>
-              <a:rPr lang="en-US" smtClean="0"/>
+              <a:rPr lang="en-US"/>
               <a:t>Fifth level</a:t>
             </a:r>
-            <a:endParaRPr lang="en-US"/>
           </a:p>
         </p:txBody>
       </p:sp>
@@ -1309,38 +1314,37 @@
           <a:p>
             <a:pPr lvl="0"/>
             <a:r>
-              <a:rPr lang="en-US" smtClean="0"/>
+              <a:rPr lang="en-US"/>
               <a:t>Click to edit Master text styles</a:t>
             </a:r>
           </a:p>
           <a:p>
             <a:pPr lvl="1"/>
             <a:r>
-              <a:rPr lang="en-US" smtClean="0"/>
+              <a:rPr lang="en-US"/>
               <a:t>Second level</a:t>
             </a:r>
           </a:p>
           <a:p>
             <a:pPr lvl="2"/>
             <a:r>
-              <a:rPr lang="en-US" smtClean="0"/>
+              <a:rPr lang="en-US"/>
               <a:t>Third level</a:t>
             </a:r>
           </a:p>
           <a:p>
             <a:pPr lvl="3"/>
             <a:r>
-              <a:rPr lang="en-US" smtClean="0"/>
+              <a:rPr lang="en-US"/>
               <a:t>Fourth level</a:t>
             </a:r>
           </a:p>
           <a:p>
             <a:pPr lvl="4"/>
             <a:r>
-              <a:rPr lang="en-US" smtClean="0"/>
+              <a:rPr lang="en-US"/>
               <a:t>Fifth level</a:t>
             </a:r>
-            <a:endParaRPr lang="en-US"/>
           </a:p>
         </p:txBody>
       </p:sp>
@@ -1361,7 +1365,7 @@
           <a:p>
             <a:fld id="{5BCAD085-E8A6-8845-BD4E-CB4CCA059FC4}" type="datetimeFigureOut">
               <a:rPr lang="en-US" smtClean="0"/>
-              <a:t>1/27/13</a:t>
+              <a:t>7/20/2026</a:t>
             </a:fld>
             <a:endParaRPr lang="en-US"/>
           </a:p>
@@ -1403,7 +1407,7 @@
           <a:p>
             <a:fld id="{C1FF6DA9-008F-8B48-92A6-B652298478BF}" type="slidenum">
               <a:rPr lang="en-US" smtClean="0"/>
-              <a:t>‹#›</a:t>
+              <a:t>‹N°›</a:t>
             </a:fld>
             <a:endParaRPr lang="en-US"/>
           </a:p>
@@ -1459,10 +1463,9 @@
           </a:lstStyle>
           <a:p>
             <a:r>
-              <a:rPr lang="en-US" smtClean="0"/>
+              <a:rPr lang="en-US"/>
               <a:t>Click to edit Master title style</a:t>
             </a:r>
-            <a:endParaRPr lang="en-US"/>
           </a:p>
         </p:txBody>
       </p:sp>
@@ -1525,7 +1528,7 @@
           <a:p>
             <a:pPr lvl="0"/>
             <a:r>
-              <a:rPr lang="en-US" smtClean="0"/>
+              <a:rPr lang="en-US"/>
               <a:t>Click to edit Master text styles</a:t>
             </a:r>
           </a:p>
@@ -1581,38 +1584,37 @@
           <a:p>
             <a:pPr lvl="0"/>
             <a:r>
-              <a:rPr lang="en-US" smtClean="0"/>
+              <a:rPr lang="en-US"/>
               <a:t>Click to edit Master text styles</a:t>
             </a:r>
           </a:p>
           <a:p>
             <a:pPr lvl="1"/>
             <a:r>
-              <a:rPr lang="en-US" smtClean="0"/>
+              <a:rPr lang="en-US"/>
               <a:t>Second level</a:t>
             </a:r>
           </a:p>
           <a:p>
             <a:pPr lvl="2"/>
             <a:r>
-              <a:rPr lang="en-US" smtClean="0"/>
+              <a:rPr lang="en-US"/>
               <a:t>Third level</a:t>
             </a:r>
           </a:p>
           <a:p>
             <a:pPr lvl="3"/>
             <a:r>
-              <a:rPr lang="en-US" smtClean="0"/>
+              <a:rPr lang="en-US"/>
               <a:t>Fourth level</a:t>
             </a:r>
           </a:p>
           <a:p>
             <a:pPr lvl="4"/>
             <a:r>
-              <a:rPr lang="en-US" smtClean="0"/>
+              <a:rPr lang="en-US"/>
               <a:t>Fifth level</a:t>
             </a:r>
-            <a:endParaRPr lang="en-US"/>
           </a:p>
         </p:txBody>
       </p:sp>
@@ -1675,7 +1677,7 @@
           <a:p>
             <a:pPr lvl="0"/>
             <a:r>
-              <a:rPr lang="en-US" smtClean="0"/>
+              <a:rPr lang="en-US"/>
               <a:t>Click to edit Master text styles</a:t>
             </a:r>
           </a:p>
@@ -1731,38 +1733,37 @@
           <a:p>
             <a:pPr lvl="0"/>
             <a:r>
-              <a:rPr lang="en-US" smtClean="0"/>
+              <a:rPr lang="en-US"/>
               <a:t>Click to edit Master text styles</a:t>
             </a:r>
           </a:p>
           <a:p>
             <a:pPr lvl="1"/>
             <a:r>
-              <a:rPr lang="en-US" smtClean="0"/>
+              <a:rPr lang="en-US"/>
               <a:t>Second level</a:t>
             </a:r>
           </a:p>
           <a:p>
             <a:pPr lvl="2"/>
             <a:r>
-              <a:rPr lang="en-US" smtClean="0"/>
+              <a:rPr lang="en-US"/>
               <a:t>Third level</a:t>
             </a:r>
           </a:p>
           <a:p>
             <a:pPr lvl="3"/>
             <a:r>
-              <a:rPr lang="en-US" smtClean="0"/>
+              <a:rPr lang="en-US"/>
               <a:t>Fourth level</a:t>
             </a:r>
           </a:p>
           <a:p>
             <a:pPr lvl="4"/>
             <a:r>
-              <a:rPr lang="en-US" smtClean="0"/>
+              <a:rPr lang="en-US"/>
               <a:t>Fifth level</a:t>
             </a:r>
-            <a:endParaRPr lang="en-US"/>
           </a:p>
         </p:txBody>
       </p:sp>
@@ -1783,7 +1784,7 @@
           <a:p>
             <a:fld id="{5BCAD085-E8A6-8845-BD4E-CB4CCA059FC4}" type="datetimeFigureOut">
               <a:rPr lang="en-US" smtClean="0"/>
-              <a:t>1/27/13</a:t>
+              <a:t>7/20/2026</a:t>
             </a:fld>
             <a:endParaRPr lang="en-US"/>
           </a:p>
@@ -1825,7 +1826,7 @@
           <a:p>
             <a:fld id="{C1FF6DA9-008F-8B48-92A6-B652298478BF}" type="slidenum">
               <a:rPr lang="en-US" smtClean="0"/>
-              <a:t>‹#›</a:t>
+              <a:t>‹N°›</a:t>
             </a:fld>
             <a:endParaRPr lang="en-US"/>
           </a:p>
@@ -1877,10 +1878,9 @@
           <a:lstStyle/>
           <a:p>
             <a:r>
-              <a:rPr lang="en-US" smtClean="0"/>
+              <a:rPr lang="en-US"/>
               <a:t>Click to edit Master title style</a:t>
             </a:r>
-            <a:endParaRPr lang="en-US"/>
           </a:p>
         </p:txBody>
       </p:sp>
@@ -1901,7 +1901,7 @@
           <a:p>
             <a:fld id="{5BCAD085-E8A6-8845-BD4E-CB4CCA059FC4}" type="datetimeFigureOut">
               <a:rPr lang="en-US" smtClean="0"/>
-              <a:t>1/27/13</a:t>
+              <a:t>7/20/2026</a:t>
             </a:fld>
             <a:endParaRPr lang="en-US"/>
           </a:p>
@@ -1943,7 +1943,7 @@
           <a:p>
             <a:fld id="{C1FF6DA9-008F-8B48-92A6-B652298478BF}" type="slidenum">
               <a:rPr lang="en-US" smtClean="0"/>
-              <a:t>‹#›</a:t>
+              <a:t>‹N°›</a:t>
             </a:fld>
             <a:endParaRPr lang="en-US"/>
           </a:p>
@@ -1996,7 +1996,7 @@
           <a:p>
             <a:fld id="{5BCAD085-E8A6-8845-BD4E-CB4CCA059FC4}" type="datetimeFigureOut">
               <a:rPr lang="en-US" smtClean="0"/>
-              <a:t>1/27/13</a:t>
+              <a:t>7/20/2026</a:t>
             </a:fld>
             <a:endParaRPr lang="en-US"/>
           </a:p>
@@ -2038,7 +2038,7 @@
           <a:p>
             <a:fld id="{C1FF6DA9-008F-8B48-92A6-B652298478BF}" type="slidenum">
               <a:rPr lang="en-US" smtClean="0"/>
-              <a:t>‹#›</a:t>
+              <a:t>‹N°›</a:t>
             </a:fld>
             <a:endParaRPr lang="en-US"/>
           </a:p>
@@ -2099,10 +2099,9 @@
           </a:lstStyle>
           <a:p>
             <a:r>
-              <a:rPr lang="en-US" smtClean="0"/>
+              <a:rPr lang="en-US"/>
               <a:t>Click to edit Master title style</a:t>
             </a:r>
-            <a:endParaRPr lang="en-US"/>
           </a:p>
         </p:txBody>
       </p:sp>
@@ -2156,38 +2155,37 @@
           <a:p>
             <a:pPr lvl="0"/>
             <a:r>
-              <a:rPr lang="en-US" smtClean="0"/>
+              <a:rPr lang="en-US"/>
               <a:t>Click to edit Master text styles</a:t>
             </a:r>
           </a:p>
           <a:p>
             <a:pPr lvl="1"/>
             <a:r>
-              <a:rPr lang="en-US" smtClean="0"/>
+              <a:rPr lang="en-US"/>
               <a:t>Second level</a:t>
             </a:r>
           </a:p>
           <a:p>
             <a:pPr lvl="2"/>
             <a:r>
-              <a:rPr lang="en-US" smtClean="0"/>
+              <a:rPr lang="en-US"/>
               <a:t>Third level</a:t>
             </a:r>
           </a:p>
           <a:p>
             <a:pPr lvl="3"/>
             <a:r>
-              <a:rPr lang="en-US" smtClean="0"/>
+              <a:rPr lang="en-US"/>
               <a:t>Fourth level</a:t>
             </a:r>
           </a:p>
           <a:p>
             <a:pPr lvl="4"/>
             <a:r>
-              <a:rPr lang="en-US" smtClean="0"/>
+              <a:rPr lang="en-US"/>
               <a:t>Fifth level</a:t>
             </a:r>
-            <a:endParaRPr lang="en-US"/>
           </a:p>
         </p:txBody>
       </p:sp>
@@ -2250,7 +2248,7 @@
           <a:p>
             <a:pPr lvl="0"/>
             <a:r>
-              <a:rPr lang="en-US" smtClean="0"/>
+              <a:rPr lang="en-US"/>
               <a:t>Click to edit Master text styles</a:t>
             </a:r>
           </a:p>
@@ -2273,7 +2271,7 @@
           <a:p>
             <a:fld id="{5BCAD085-E8A6-8845-BD4E-CB4CCA059FC4}" type="datetimeFigureOut">
               <a:rPr lang="en-US" smtClean="0"/>
-              <a:t>1/27/13</a:t>
+              <a:t>7/20/2026</a:t>
             </a:fld>
             <a:endParaRPr lang="en-US"/>
           </a:p>
@@ -2315,7 +2313,7 @@
           <a:p>
             <a:fld id="{C1FF6DA9-008F-8B48-92A6-B652298478BF}" type="slidenum">
               <a:rPr lang="en-US" smtClean="0"/>
-              <a:t>‹#›</a:t>
+              <a:t>‹N°›</a:t>
             </a:fld>
             <a:endParaRPr lang="en-US"/>
           </a:p>
@@ -2376,10 +2374,9 @@
           </a:lstStyle>
           <a:p>
             <a:r>
-              <a:rPr lang="en-US" smtClean="0"/>
+              <a:rPr lang="en-US"/>
               <a:t>Click to edit Master title style</a:t>
             </a:r>
-            <a:endParaRPr lang="en-US"/>
           </a:p>
         </p:txBody>
       </p:sp>
@@ -2503,7 +2500,7 @@
           <a:p>
             <a:pPr lvl="0"/>
             <a:r>
-              <a:rPr lang="en-US" smtClean="0"/>
+              <a:rPr lang="en-US"/>
               <a:t>Click to edit Master text styles</a:t>
             </a:r>
           </a:p>
@@ -2526,7 +2523,7 @@
           <a:p>
             <a:fld id="{5BCAD085-E8A6-8845-BD4E-CB4CCA059FC4}" type="datetimeFigureOut">
               <a:rPr lang="en-US" smtClean="0"/>
-              <a:t>1/27/13</a:t>
+              <a:t>7/20/2026</a:t>
             </a:fld>
             <a:endParaRPr lang="en-US"/>
           </a:p>
@@ -2568,7 +2565,7 @@
           <a:p>
             <a:fld id="{C1FF6DA9-008F-8B48-92A6-B652298478BF}" type="slidenum">
               <a:rPr lang="en-US" smtClean="0"/>
-              <a:t>‹#›</a:t>
+              <a:t>‹N°›</a:t>
             </a:fld>
             <a:endParaRPr lang="en-US"/>
           </a:p>
@@ -2635,10 +2632,9 @@
           <a:lstStyle/>
           <a:p>
             <a:r>
-              <a:rPr lang="en-US" smtClean="0"/>
+              <a:rPr lang="en-US"/>
               <a:t>Click to edit Master title style</a:t>
             </a:r>
-            <a:endParaRPr lang="en-US"/>
           </a:p>
         </p:txBody>
       </p:sp>
@@ -2669,38 +2665,37 @@
           <a:p>
             <a:pPr lvl="0"/>
             <a:r>
-              <a:rPr lang="en-US" smtClean="0"/>
+              <a:rPr lang="en-US"/>
               <a:t>Click to edit Master text styles</a:t>
             </a:r>
           </a:p>
           <a:p>
             <a:pPr lvl="1"/>
             <a:r>
-              <a:rPr lang="en-US" smtClean="0"/>
+              <a:rPr lang="en-US"/>
               <a:t>Second level</a:t>
             </a:r>
           </a:p>
           <a:p>
             <a:pPr lvl="2"/>
             <a:r>
-              <a:rPr lang="en-US" smtClean="0"/>
+              <a:rPr lang="en-US"/>
               <a:t>Third level</a:t>
             </a:r>
           </a:p>
           <a:p>
             <a:pPr lvl="3"/>
             <a:r>
-              <a:rPr lang="en-US" smtClean="0"/>
+              <a:rPr lang="en-US"/>
               <a:t>Fourth level</a:t>
             </a:r>
           </a:p>
           <a:p>
             <a:pPr lvl="4"/>
             <a:r>
-              <a:rPr lang="en-US" smtClean="0"/>
+              <a:rPr lang="en-US"/>
               <a:t>Fifth level</a:t>
             </a:r>
-            <a:endParaRPr lang="en-US"/>
           </a:p>
         </p:txBody>
       </p:sp>
@@ -2739,7 +2734,7 @@
           <a:p>
             <a:fld id="{5BCAD085-E8A6-8845-BD4E-CB4CCA059FC4}" type="datetimeFigureOut">
               <a:rPr lang="en-US" smtClean="0"/>
-              <a:t>1/27/13</a:t>
+              <a:t>7/20/2026</a:t>
             </a:fld>
             <a:endParaRPr lang="en-US"/>
           </a:p>
@@ -2817,7 +2812,7 @@
           <a:p>
             <a:fld id="{C1FF6DA9-008F-8B48-92A6-B652298478BF}" type="slidenum">
               <a:rPr lang="en-US" smtClean="0"/>
-              <a:t>‹#›</a:t>
+              <a:t>‹N°›</a:t>
             </a:fld>
             <a:endParaRPr lang="en-US"/>
           </a:p>
@@ -3098,7 +3093,7 @@
 </file>
 
 <file path=ppt/slides/slide1.xml><?xml version="1.0" encoding="utf-8"?>
-<p:sld xmlns:a="http://schemas.openxmlformats.org/drawingml/2006/main" xmlns:p="http://schemas.openxmlformats.org/presentationml/2006/main" xmlns:r="http://schemas.openxmlformats.org/officeDocument/2006/relationships">
+<p:sld xmlns:a="http://schemas.openxmlformats.org/drawingml/2006/main" xmlns:r="http://schemas.openxmlformats.org/officeDocument/2006/relationships" xmlns:p="http://schemas.openxmlformats.org/presentationml/2006/main">
   <p:cSld>
     <p:spTree>
       <p:nvGrpSpPr>
@@ -3106,7 +3101,14 @@
         <p:cNvGrpSpPr/>
         <p:nvPr/>
       </p:nvGrpSpPr>
-      <p:grpSpPr/>
+      <p:grpSpPr>
+        <a:xfrm>
+          <a:off x="0" y="0"/>
+          <a:ext cx="0" cy="0"/>
+          <a:chOff x="0" y="0"/>
+          <a:chExt cx="0" cy="0"/>
+        </a:xfrm>
+      </p:grpSpPr>
       <p:sp>
         <p:nvSpPr>
           <p:cNvPr id="2" name="Rectangle 1"/>
@@ -3147,6 +3149,7 @@
           <a:lstStyle/>
           <a:p>
             <a:pPr algn="ctr"/>
+            <a:endParaRPr/>
           </a:p>
         </p:txBody>
       </p:sp>
@@ -3260,6 +3263,7 @@
           <a:lstStyle/>
           <a:p>
             <a:pPr algn="ctr"/>
+            <a:endParaRPr/>
           </a:p>
         </p:txBody>
       </p:sp>
@@ -3342,7 +3346,7 @@
 </file>
 
 <file path=ppt/slides/slide10.xml><?xml version="1.0" encoding="utf-8"?>
-<p:sld xmlns:a="http://schemas.openxmlformats.org/drawingml/2006/main" xmlns:p="http://schemas.openxmlformats.org/presentationml/2006/main" xmlns:r="http://schemas.openxmlformats.org/officeDocument/2006/relationships">
+<p:sld xmlns:a="http://schemas.openxmlformats.org/drawingml/2006/main" xmlns:r="http://schemas.openxmlformats.org/officeDocument/2006/relationships" xmlns:p="http://schemas.openxmlformats.org/presentationml/2006/main">
   <p:cSld>
     <p:spTree>
       <p:nvGrpSpPr>
@@ -3350,7 +3354,14 @@
         <p:cNvGrpSpPr/>
         <p:nvPr/>
       </p:nvGrpSpPr>
-      <p:grpSpPr/>
+      <p:grpSpPr>
+        <a:xfrm>
+          <a:off x="0" y="0"/>
+          <a:ext cx="0" cy="0"/>
+          <a:chOff x="0" y="0"/>
+          <a:chExt cx="0" cy="0"/>
+        </a:xfrm>
+      </p:grpSpPr>
       <p:sp>
         <p:nvSpPr>
           <p:cNvPr id="2" name="TextBox 1"/>
@@ -3425,6 +3436,7 @@
           <a:lstStyle/>
           <a:p>
             <a:pPr algn="ctr"/>
+            <a:endParaRPr/>
           </a:p>
         </p:txBody>
       </p:sp>
@@ -3468,6 +3480,7 @@
           <a:lstStyle/>
           <a:p>
             <a:pPr algn="ctr"/>
+            <a:endParaRPr/>
           </a:p>
         </p:txBody>
       </p:sp>
@@ -3503,7 +3516,7 @@
         </p:nvSpPr>
         <p:spPr>
           <a:xfrm>
-            <a:off x="7963919" y="2008800"/>
+            <a:off x="7963920" y="2766240"/>
             <a:ext cx="3509280" cy="1328400"/>
           </a:xfrm>
           <a:prstGeom prst="roundRect">
@@ -3537,6 +3550,7 @@
           <a:lstStyle/>
           <a:p>
             <a:pPr algn="ctr"/>
+            <a:endParaRPr/>
           </a:p>
         </p:txBody>
       </p:sp>
@@ -3548,7 +3562,7 @@
         </p:nvSpPr>
         <p:spPr>
           <a:xfrm>
-            <a:off x="7963919" y="2008800"/>
+            <a:off x="7963920" y="2766240"/>
             <a:ext cx="3509280" cy="79200"/>
           </a:xfrm>
           <a:prstGeom prst="rect">
@@ -3580,6 +3594,7 @@
           <a:lstStyle/>
           <a:p>
             <a:pPr algn="ctr"/>
+            <a:endParaRPr/>
           </a:p>
         </p:txBody>
       </p:sp>
@@ -3591,7 +3606,7 @@
         </p:nvSpPr>
         <p:spPr>
           <a:xfrm>
-            <a:off x="8107919" y="2194776"/>
+            <a:off x="8107920" y="2952216"/>
             <a:ext cx="3221280" cy="611064"/>
           </a:xfrm>
           <a:prstGeom prst="rect">
@@ -3626,7 +3641,7 @@
         </p:nvSpPr>
         <p:spPr>
           <a:xfrm>
-            <a:off x="8107919" y="2832408"/>
+            <a:off x="8107920" y="3589848"/>
             <a:ext cx="3221280" cy="438372"/>
           </a:xfrm>
           <a:prstGeom prst="rect">
@@ -3661,7 +3676,7 @@
         </p:nvSpPr>
         <p:spPr>
           <a:xfrm>
-            <a:off x="7963919" y="3589199"/>
+            <a:off x="7963920" y="4346639"/>
             <a:ext cx="3509280" cy="1328400"/>
           </a:xfrm>
           <a:prstGeom prst="roundRect">
@@ -3695,6 +3710,7 @@
           <a:lstStyle/>
           <a:p>
             <a:pPr algn="ctr"/>
+            <a:endParaRPr/>
           </a:p>
         </p:txBody>
       </p:sp>
@@ -3706,7 +3722,7 @@
         </p:nvSpPr>
         <p:spPr>
           <a:xfrm>
-            <a:off x="7963919" y="3589199"/>
+            <a:off x="7963920" y="4346639"/>
             <a:ext cx="3509280" cy="79200"/>
           </a:xfrm>
           <a:prstGeom prst="rect">
@@ -3738,6 +3754,7 @@
           <a:lstStyle/>
           <a:p>
             <a:pPr algn="ctr"/>
+            <a:endParaRPr/>
           </a:p>
         </p:txBody>
       </p:sp>
@@ -3749,7 +3766,7 @@
         </p:nvSpPr>
         <p:spPr>
           <a:xfrm>
-            <a:off x="8107919" y="3775175"/>
+            <a:off x="8107920" y="4532615"/>
             <a:ext cx="3221280" cy="611064"/>
           </a:xfrm>
           <a:prstGeom prst="rect">
@@ -3784,7 +3801,7 @@
         </p:nvSpPr>
         <p:spPr>
           <a:xfrm>
-            <a:off x="8107919" y="4412808"/>
+            <a:off x="8107920" y="5170248"/>
             <a:ext cx="3221280" cy="438372"/>
           </a:xfrm>
           <a:prstGeom prst="rect">
@@ -3807,165 +3824,6 @@
                 <a:latin typeface="Aptos Display"/>
               </a:rPr>
               <a:t>Accuracy globale</a:t>
-            </a:r>
-          </a:p>
-        </p:txBody>
-      </p:sp>
-      <p:sp>
-        <p:nvSpPr>
-          <p:cNvPr id="14" name="Rounded Rectangle 13"/>
-          <p:cNvSpPr/>
-          <p:nvPr/>
-        </p:nvSpPr>
-        <p:spPr>
-          <a:xfrm>
-            <a:off x="7963919" y="5169600"/>
-            <a:ext cx="3509280" cy="1328400"/>
-          </a:xfrm>
-          <a:prstGeom prst="roundRect">
-            <a:avLst>
-              <a:gd name="adj" fmla="val 10000"/>
-            </a:avLst>
-          </a:prstGeom>
-          <a:solidFill>
-            <a:srgbClr val="F2F2F2"/>
-          </a:solidFill>
-          <a:ln>
-            <a:noFill/>
-          </a:ln>
-        </p:spPr>
-        <p:style>
-          <a:lnRef idx="1">
-            <a:schemeClr val="accent1"/>
-          </a:lnRef>
-          <a:fillRef idx="3">
-            <a:schemeClr val="accent1"/>
-          </a:fillRef>
-          <a:effectRef idx="2">
-            <a:schemeClr val="accent1"/>
-          </a:effectRef>
-          <a:fontRef idx="minor">
-            <a:schemeClr val="lt1"/>
-          </a:fontRef>
-        </p:style>
-        <p:txBody>
-          <a:bodyPr rtlCol="0" anchor="ctr"/>
-          <a:lstStyle/>
-          <a:p>
-            <a:pPr algn="ctr"/>
-          </a:p>
-        </p:txBody>
-      </p:sp>
-      <p:sp>
-        <p:nvSpPr>
-          <p:cNvPr id="15" name="Rectangle 14"/>
-          <p:cNvSpPr/>
-          <p:nvPr/>
-        </p:nvSpPr>
-        <p:spPr>
-          <a:xfrm>
-            <a:off x="7963919" y="5169600"/>
-            <a:ext cx="3509280" cy="79200"/>
-          </a:xfrm>
-          <a:prstGeom prst="rect">
-            <a:avLst/>
-          </a:prstGeom>
-          <a:solidFill>
-            <a:srgbClr val="888888"/>
-          </a:solidFill>
-          <a:ln>
-            <a:noFill/>
-          </a:ln>
-        </p:spPr>
-        <p:style>
-          <a:lnRef idx="1">
-            <a:schemeClr val="accent1"/>
-          </a:lnRef>
-          <a:fillRef idx="3">
-            <a:schemeClr val="accent1"/>
-          </a:fillRef>
-          <a:effectRef idx="2">
-            <a:schemeClr val="accent1"/>
-          </a:effectRef>
-          <a:fontRef idx="minor">
-            <a:schemeClr val="lt1"/>
-          </a:fontRef>
-        </p:style>
-        <p:txBody>
-          <a:bodyPr rtlCol="0" anchor="ctr"/>
-          <a:lstStyle/>
-          <a:p>
-            <a:pPr algn="ctr"/>
-          </a:p>
-        </p:txBody>
-      </p:sp>
-      <p:sp>
-        <p:nvSpPr>
-          <p:cNvPr id="16" name="TextBox 15"/>
-          <p:cNvSpPr txBox="1"/>
-          <p:nvPr/>
-        </p:nvSpPr>
-        <p:spPr>
-          <a:xfrm>
-            <a:off x="8107919" y="5355576"/>
-            <a:ext cx="3221280" cy="611064"/>
-          </a:xfrm>
-          <a:prstGeom prst="rect">
-            <a:avLst/>
-          </a:prstGeom>
-          <a:noFill/>
-        </p:spPr>
-        <p:txBody>
-          <a:bodyPr wrap="square">
-            <a:spAutoFit/>
-          </a:bodyPr>
-          <a:lstStyle/>
-          <a:p>
-            <a:pPr algn="ctr"/>
-            <a:r>
-              <a:rPr sz="4000" b="1">
-                <a:solidFill>
-                  <a:srgbClr val="888888"/>
-                </a:solidFill>
-                <a:latin typeface="Aptos Display"/>
-              </a:rPr>
-              <a:t>—</a:t>
-            </a:r>
-          </a:p>
-        </p:txBody>
-      </p:sp>
-      <p:sp>
-        <p:nvSpPr>
-          <p:cNvPr id="17" name="TextBox 16"/>
-          <p:cNvSpPr txBox="1"/>
-          <p:nvPr/>
-        </p:nvSpPr>
-        <p:spPr>
-          <a:xfrm>
-            <a:off x="8107919" y="5993208"/>
-            <a:ext cx="3221280" cy="438372"/>
-          </a:xfrm>
-          <a:prstGeom prst="rect">
-            <a:avLst/>
-          </a:prstGeom>
-          <a:noFill/>
-        </p:spPr>
-        <p:txBody>
-          <a:bodyPr wrap="square">
-            <a:spAutoFit/>
-          </a:bodyPr>
-          <a:lstStyle/>
-          <a:p>
-            <a:pPr algn="ctr"/>
-            <a:r>
-              <a:rPr sz="1300" b="0">
-                <a:solidFill>
-                  <a:srgbClr val="888888"/>
-                </a:solidFill>
-                <a:latin typeface="Aptos Display"/>
-              </a:rPr>
-              <a:t>AUC-ROC
-(pas de proba)</a:t>
             </a:r>
           </a:p>
         </p:txBody>
@@ -4014,7 +3872,7 @@
 </file>
 
 <file path=ppt/slides/slide11.xml><?xml version="1.0" encoding="utf-8"?>
-<p:sld xmlns:a="http://schemas.openxmlformats.org/drawingml/2006/main" xmlns:p="http://schemas.openxmlformats.org/presentationml/2006/main" xmlns:r="http://schemas.openxmlformats.org/officeDocument/2006/relationships">
+<p:sld xmlns:a="http://schemas.openxmlformats.org/drawingml/2006/main" xmlns:r="http://schemas.openxmlformats.org/officeDocument/2006/relationships" xmlns:p="http://schemas.openxmlformats.org/presentationml/2006/main">
   <p:cSld>
     <p:spTree>
       <p:nvGrpSpPr>
@@ -4022,7 +3880,14 @@
         <p:cNvGrpSpPr/>
         <p:nvPr/>
       </p:nvGrpSpPr>
-      <p:grpSpPr/>
+      <p:grpSpPr>
+        <a:xfrm>
+          <a:off x="0" y="0"/>
+          <a:ext cx="0" cy="0"/>
+          <a:chOff x="0" y="0"/>
+          <a:chExt cx="0" cy="0"/>
+        </a:xfrm>
+      </p:grpSpPr>
       <p:sp>
         <p:nvSpPr>
           <p:cNvPr id="2" name="TextBox 1"/>
@@ -4097,6 +3962,7 @@
           <a:lstStyle/>
           <a:p>
             <a:pPr algn="ctr"/>
+            <a:endParaRPr/>
           </a:p>
         </p:txBody>
       </p:sp>
@@ -4140,6 +4006,7 @@
           <a:lstStyle/>
           <a:p>
             <a:pPr algn="ctr"/>
+            <a:endParaRPr/>
           </a:p>
         </p:txBody>
       </p:sp>
@@ -4209,6 +4076,7 @@
           <a:lstStyle/>
           <a:p>
             <a:pPr algn="ctr"/>
+            <a:endParaRPr/>
           </a:p>
         </p:txBody>
       </p:sp>
@@ -4252,6 +4120,7 @@
           <a:lstStyle/>
           <a:p>
             <a:pPr algn="ctr"/>
+            <a:endParaRPr/>
           </a:p>
         </p:txBody>
       </p:sp>
@@ -4367,6 +4236,7 @@
           <a:lstStyle/>
           <a:p>
             <a:pPr algn="ctr"/>
+            <a:endParaRPr/>
           </a:p>
         </p:txBody>
       </p:sp>
@@ -4410,6 +4280,7 @@
           <a:lstStyle/>
           <a:p>
             <a:pPr algn="ctr"/>
+            <a:endParaRPr/>
           </a:p>
         </p:txBody>
       </p:sp>
@@ -4525,6 +4396,7 @@
           <a:lstStyle/>
           <a:p>
             <a:pPr algn="ctr"/>
+            <a:endParaRPr/>
           </a:p>
         </p:txBody>
       </p:sp>
@@ -4568,6 +4440,7 @@
           <a:lstStyle/>
           <a:p>
             <a:pPr algn="ctr"/>
+            <a:endParaRPr/>
           </a:p>
         </p:txBody>
       </p:sp>
@@ -4685,7 +4558,7 @@
 </file>
 
 <file path=ppt/slides/slide12.xml><?xml version="1.0" encoding="utf-8"?>
-<p:sld xmlns:a="http://schemas.openxmlformats.org/drawingml/2006/main" xmlns:p="http://schemas.openxmlformats.org/presentationml/2006/main" xmlns:r="http://schemas.openxmlformats.org/officeDocument/2006/relationships">
+<p:sld xmlns:a="http://schemas.openxmlformats.org/drawingml/2006/main" xmlns:r="http://schemas.openxmlformats.org/officeDocument/2006/relationships" xmlns:p="http://schemas.openxmlformats.org/presentationml/2006/main">
   <p:cSld>
     <p:spTree>
       <p:nvGrpSpPr>
@@ -4693,7 +4566,14 @@
         <p:cNvGrpSpPr/>
         <p:nvPr/>
       </p:nvGrpSpPr>
-      <p:grpSpPr/>
+      <p:grpSpPr>
+        <a:xfrm>
+          <a:off x="0" y="0"/>
+          <a:ext cx="0" cy="0"/>
+          <a:chOff x="0" y="0"/>
+          <a:chExt cx="0" cy="0"/>
+        </a:xfrm>
+      </p:grpSpPr>
       <p:sp>
         <p:nvSpPr>
           <p:cNvPr id="2" name="TextBox 1"/>
@@ -4768,6 +4648,7 @@
           <a:lstStyle/>
           <a:p>
             <a:pPr algn="ctr"/>
+            <a:endParaRPr/>
           </a:p>
         </p:txBody>
       </p:sp>
@@ -4811,6 +4692,7 @@
           <a:lstStyle/>
           <a:p>
             <a:pPr algn="ctr"/>
+            <a:endParaRPr/>
           </a:p>
         </p:txBody>
       </p:sp>
@@ -4880,6 +4762,7 @@
           <a:lstStyle/>
           <a:p>
             <a:pPr algn="ctr"/>
+            <a:endParaRPr/>
           </a:p>
         </p:txBody>
       </p:sp>
@@ -4923,6 +4806,7 @@
           <a:lstStyle/>
           <a:p>
             <a:pPr algn="ctr"/>
+            <a:endParaRPr/>
           </a:p>
         </p:txBody>
       </p:sp>
@@ -5038,6 +4922,7 @@
           <a:lstStyle/>
           <a:p>
             <a:pPr algn="ctr"/>
+            <a:endParaRPr/>
           </a:p>
         </p:txBody>
       </p:sp>
@@ -5081,6 +4966,7 @@
           <a:lstStyle/>
           <a:p>
             <a:pPr algn="ctr"/>
+            <a:endParaRPr/>
           </a:p>
         </p:txBody>
       </p:sp>
@@ -5196,6 +5082,7 @@
           <a:lstStyle/>
           <a:p>
             <a:pPr algn="ctr"/>
+            <a:endParaRPr/>
           </a:p>
         </p:txBody>
       </p:sp>
@@ -5239,6 +5126,7 @@
           <a:lstStyle/>
           <a:p>
             <a:pPr algn="ctr"/>
+            <a:endParaRPr/>
           </a:p>
         </p:txBody>
       </p:sp>
@@ -5356,7 +5244,7 @@
 </file>
 
 <file path=ppt/slides/slide13.xml><?xml version="1.0" encoding="utf-8"?>
-<p:sld xmlns:a="http://schemas.openxmlformats.org/drawingml/2006/main" xmlns:p="http://schemas.openxmlformats.org/presentationml/2006/main" xmlns:r="http://schemas.openxmlformats.org/officeDocument/2006/relationships">
+<p:sld xmlns:a="http://schemas.openxmlformats.org/drawingml/2006/main" xmlns:r="http://schemas.openxmlformats.org/officeDocument/2006/relationships" xmlns:p="http://schemas.openxmlformats.org/presentationml/2006/main">
   <p:cSld>
     <p:spTree>
       <p:nvGrpSpPr>
@@ -5364,7 +5252,14 @@
         <p:cNvGrpSpPr/>
         <p:nvPr/>
       </p:nvGrpSpPr>
-      <p:grpSpPr/>
+      <p:grpSpPr>
+        <a:xfrm>
+          <a:off x="0" y="0"/>
+          <a:ext cx="0" cy="0"/>
+          <a:chOff x="0" y="0"/>
+          <a:chExt cx="0" cy="0"/>
+        </a:xfrm>
+      </p:grpSpPr>
       <p:sp>
         <p:nvSpPr>
           <p:cNvPr id="2" name="TextBox 1"/>
@@ -5439,6 +5334,7 @@
           <a:lstStyle/>
           <a:p>
             <a:pPr algn="ctr"/>
+            <a:endParaRPr/>
           </a:p>
         </p:txBody>
       </p:sp>
@@ -5482,6 +5378,7 @@
           <a:lstStyle/>
           <a:p>
             <a:pPr algn="ctr"/>
+            <a:endParaRPr/>
           </a:p>
         </p:txBody>
       </p:sp>
@@ -5551,6 +5448,7 @@
           <a:lstStyle/>
           <a:p>
             <a:pPr algn="ctr"/>
+            <a:endParaRPr/>
           </a:p>
         </p:txBody>
       </p:sp>
@@ -5594,6 +5492,7 @@
           <a:lstStyle/>
           <a:p>
             <a:pPr algn="ctr"/>
+            <a:endParaRPr/>
           </a:p>
         </p:txBody>
       </p:sp>
@@ -5709,6 +5608,7 @@
           <a:lstStyle/>
           <a:p>
             <a:pPr algn="ctr"/>
+            <a:endParaRPr/>
           </a:p>
         </p:txBody>
       </p:sp>
@@ -5752,6 +5652,7 @@
           <a:lstStyle/>
           <a:p>
             <a:pPr algn="ctr"/>
+            <a:endParaRPr/>
           </a:p>
         </p:txBody>
       </p:sp>
@@ -5867,6 +5768,7 @@
           <a:lstStyle/>
           <a:p>
             <a:pPr algn="ctr"/>
+            <a:endParaRPr/>
           </a:p>
         </p:txBody>
       </p:sp>
@@ -5910,6 +5812,7 @@
           <a:lstStyle/>
           <a:p>
             <a:pPr algn="ctr"/>
+            <a:endParaRPr/>
           </a:p>
         </p:txBody>
       </p:sp>
@@ -6027,7 +5930,7 @@
 </file>
 
 <file path=ppt/slides/slide14.xml><?xml version="1.0" encoding="utf-8"?>
-<p:sld xmlns:a="http://schemas.openxmlformats.org/drawingml/2006/main" xmlns:p="http://schemas.openxmlformats.org/presentationml/2006/main" xmlns:r="http://schemas.openxmlformats.org/officeDocument/2006/relationships">
+<p:sld xmlns:a="http://schemas.openxmlformats.org/drawingml/2006/main" xmlns:r="http://schemas.openxmlformats.org/officeDocument/2006/relationships" xmlns:p="http://schemas.openxmlformats.org/presentationml/2006/main">
   <p:cSld>
     <p:spTree>
       <p:nvGrpSpPr>
@@ -6035,7 +5938,14 @@
         <p:cNvGrpSpPr/>
         <p:nvPr/>
       </p:nvGrpSpPr>
-      <p:grpSpPr/>
+      <p:grpSpPr>
+        <a:xfrm>
+          <a:off x="0" y="0"/>
+          <a:ext cx="0" cy="0"/>
+          <a:chOff x="0" y="0"/>
+          <a:chExt cx="0" cy="0"/>
+        </a:xfrm>
+      </p:grpSpPr>
       <p:sp>
         <p:nvSpPr>
           <p:cNvPr id="2" name="TextBox 1"/>
@@ -6110,6 +6020,7 @@
           <a:lstStyle/>
           <a:p>
             <a:pPr algn="ctr"/>
+            <a:endParaRPr/>
           </a:p>
         </p:txBody>
       </p:sp>
@@ -6153,6 +6064,7 @@
           <a:lstStyle/>
           <a:p>
             <a:pPr algn="ctr"/>
+            <a:endParaRPr/>
           </a:p>
         </p:txBody>
       </p:sp>
@@ -6222,6 +6134,7 @@
           <a:lstStyle/>
           <a:p>
             <a:pPr algn="ctr"/>
+            <a:endParaRPr/>
           </a:p>
         </p:txBody>
       </p:sp>
@@ -6265,6 +6178,7 @@
           <a:lstStyle/>
           <a:p>
             <a:pPr algn="ctr"/>
+            <a:endParaRPr/>
           </a:p>
         </p:txBody>
       </p:sp>
@@ -6380,6 +6294,7 @@
           <a:lstStyle/>
           <a:p>
             <a:pPr algn="ctr"/>
+            <a:endParaRPr/>
           </a:p>
         </p:txBody>
       </p:sp>
@@ -6423,6 +6338,7 @@
           <a:lstStyle/>
           <a:p>
             <a:pPr algn="ctr"/>
+            <a:endParaRPr/>
           </a:p>
         </p:txBody>
       </p:sp>
@@ -6538,6 +6454,7 @@
           <a:lstStyle/>
           <a:p>
             <a:pPr algn="ctr"/>
+            <a:endParaRPr/>
           </a:p>
         </p:txBody>
       </p:sp>
@@ -6581,6 +6498,7 @@
           <a:lstStyle/>
           <a:p>
             <a:pPr algn="ctr"/>
+            <a:endParaRPr/>
           </a:p>
         </p:txBody>
       </p:sp>
@@ -6698,7 +6616,7 @@
 </file>
 
 <file path=ppt/slides/slide15.xml><?xml version="1.0" encoding="utf-8"?>
-<p:sld xmlns:a="http://schemas.openxmlformats.org/drawingml/2006/main" xmlns:p="http://schemas.openxmlformats.org/presentationml/2006/main" xmlns:r="http://schemas.openxmlformats.org/officeDocument/2006/relationships">
+<p:sld xmlns:a="http://schemas.openxmlformats.org/drawingml/2006/main" xmlns:r="http://schemas.openxmlformats.org/officeDocument/2006/relationships" xmlns:p="http://schemas.openxmlformats.org/presentationml/2006/main">
   <p:cSld>
     <p:spTree>
       <p:nvGrpSpPr>
@@ -6706,7 +6624,14 @@
         <p:cNvGrpSpPr/>
         <p:nvPr/>
       </p:nvGrpSpPr>
-      <p:grpSpPr/>
+      <p:grpSpPr>
+        <a:xfrm>
+          <a:off x="0" y="0"/>
+          <a:ext cx="0" cy="0"/>
+          <a:chOff x="0" y="0"/>
+          <a:chExt cx="0" cy="0"/>
+        </a:xfrm>
+      </p:grpSpPr>
       <p:sp>
         <p:nvSpPr>
           <p:cNvPr id="2" name="TextBox 1"/>
@@ -6781,6 +6706,7 @@
           <a:lstStyle/>
           <a:p>
             <a:pPr algn="ctr"/>
+            <a:endParaRPr/>
           </a:p>
         </p:txBody>
       </p:sp>
@@ -6824,6 +6750,7 @@
           <a:lstStyle/>
           <a:p>
             <a:pPr algn="ctr"/>
+            <a:endParaRPr/>
           </a:p>
         </p:txBody>
       </p:sp>
@@ -6867,6 +6794,7 @@
           <a:lstStyle/>
           <a:p>
             <a:pPr algn="ctr"/>
+            <a:endParaRPr/>
           </a:p>
         </p:txBody>
       </p:sp>
@@ -6910,6 +6838,7 @@
           <a:lstStyle/>
           <a:p>
             <a:pPr algn="ctr"/>
+            <a:endParaRPr/>
           </a:p>
         </p:txBody>
       </p:sp>
@@ -7024,6 +6953,7 @@
           <a:lstStyle/>
           <a:p>
             <a:pPr algn="ctr"/>
+            <a:endParaRPr/>
           </a:p>
         </p:txBody>
       </p:sp>
@@ -7067,6 +6997,7 @@
           <a:lstStyle/>
           <a:p>
             <a:pPr algn="ctr"/>
+            <a:endParaRPr/>
           </a:p>
         </p:txBody>
       </p:sp>
@@ -7181,6 +7112,7 @@
           <a:lstStyle/>
           <a:p>
             <a:pPr algn="ctr"/>
+            <a:endParaRPr/>
           </a:p>
         </p:txBody>
       </p:sp>
@@ -7224,6 +7156,7 @@
           <a:lstStyle/>
           <a:p>
             <a:pPr algn="ctr"/>
+            <a:endParaRPr/>
           </a:p>
         </p:txBody>
       </p:sp>
@@ -7338,6 +7271,7 @@
           <a:lstStyle/>
           <a:p>
             <a:pPr algn="ctr"/>
+            <a:endParaRPr/>
           </a:p>
         </p:txBody>
       </p:sp>
@@ -7381,6 +7315,7 @@
           <a:lstStyle/>
           <a:p>
             <a:pPr algn="ctr"/>
+            <a:endParaRPr/>
           </a:p>
         </p:txBody>
       </p:sp>
@@ -7498,7 +7433,7 @@
 </file>
 
 <file path=ppt/slides/slide16.xml><?xml version="1.0" encoding="utf-8"?>
-<p:sld xmlns:a="http://schemas.openxmlformats.org/drawingml/2006/main" xmlns:p="http://schemas.openxmlformats.org/presentationml/2006/main" xmlns:r="http://schemas.openxmlformats.org/officeDocument/2006/relationships">
+<p:sld xmlns:a="http://schemas.openxmlformats.org/drawingml/2006/main" xmlns:r="http://schemas.openxmlformats.org/officeDocument/2006/relationships" xmlns:p="http://schemas.openxmlformats.org/presentationml/2006/main">
   <p:cSld>
     <p:spTree>
       <p:nvGrpSpPr>
@@ -7506,7 +7441,14 @@
         <p:cNvGrpSpPr/>
         <p:nvPr/>
       </p:nvGrpSpPr>
-      <p:grpSpPr/>
+      <p:grpSpPr>
+        <a:xfrm>
+          <a:off x="0" y="0"/>
+          <a:ext cx="0" cy="0"/>
+          <a:chOff x="0" y="0"/>
+          <a:chExt cx="0" cy="0"/>
+        </a:xfrm>
+      </p:grpSpPr>
       <p:sp>
         <p:nvSpPr>
           <p:cNvPr id="2" name="Rectangle 1"/>
@@ -7547,6 +7489,7 @@
           <a:lstStyle/>
           <a:p>
             <a:pPr algn="ctr"/>
+            <a:endParaRPr/>
           </a:p>
         </p:txBody>
       </p:sp>
@@ -7664,7 +7607,7 @@
 </file>
 
 <file path=ppt/slides/slide17.xml><?xml version="1.0" encoding="utf-8"?>
-<p:sld xmlns:a="http://schemas.openxmlformats.org/drawingml/2006/main" xmlns:p="http://schemas.openxmlformats.org/presentationml/2006/main" xmlns:r="http://schemas.openxmlformats.org/officeDocument/2006/relationships">
+<p:sld xmlns:a="http://schemas.openxmlformats.org/drawingml/2006/main" xmlns:r="http://schemas.openxmlformats.org/officeDocument/2006/relationships" xmlns:p="http://schemas.openxmlformats.org/presentationml/2006/main">
   <p:cSld>
     <p:spTree>
       <p:nvGrpSpPr>
@@ -7672,7 +7615,14 @@
         <p:cNvGrpSpPr/>
         <p:nvPr/>
       </p:nvGrpSpPr>
-      <p:grpSpPr/>
+      <p:grpSpPr>
+        <a:xfrm>
+          <a:off x="0" y="0"/>
+          <a:ext cx="0" cy="0"/>
+          <a:chOff x="0" y="0"/>
+          <a:chExt cx="0" cy="0"/>
+        </a:xfrm>
+      </p:grpSpPr>
       <p:sp>
         <p:nvSpPr>
           <p:cNvPr id="2" name="TextBox 1"/>
@@ -7747,6 +7697,7 @@
           <a:lstStyle/>
           <a:p>
             <a:pPr algn="ctr"/>
+            <a:endParaRPr/>
           </a:p>
         </p:txBody>
       </p:sp>
@@ -7790,6 +7741,7 @@
           <a:lstStyle/>
           <a:p>
             <a:pPr algn="ctr"/>
+            <a:endParaRPr/>
           </a:p>
         </p:txBody>
       </p:sp>
@@ -7833,6 +7785,7 @@
           <a:lstStyle/>
           <a:p>
             <a:pPr algn="ctr"/>
+            <a:endParaRPr/>
           </a:p>
         </p:txBody>
       </p:sp>
@@ -7876,6 +7829,7 @@
           <a:lstStyle/>
           <a:p>
             <a:pPr algn="ctr"/>
+            <a:endParaRPr/>
           </a:p>
         </p:txBody>
       </p:sp>
@@ -7990,6 +7944,7 @@
           <a:lstStyle/>
           <a:p>
             <a:pPr algn="ctr"/>
+            <a:endParaRPr/>
           </a:p>
         </p:txBody>
       </p:sp>
@@ -8033,6 +7988,7 @@
           <a:lstStyle/>
           <a:p>
             <a:pPr algn="ctr"/>
+            <a:endParaRPr/>
           </a:p>
         </p:txBody>
       </p:sp>
@@ -8147,6 +8103,7 @@
           <a:lstStyle/>
           <a:p>
             <a:pPr algn="ctr"/>
+            <a:endParaRPr/>
           </a:p>
         </p:txBody>
       </p:sp>
@@ -8190,6 +8147,7 @@
           <a:lstStyle/>
           <a:p>
             <a:pPr algn="ctr"/>
+            <a:endParaRPr/>
           </a:p>
         </p:txBody>
       </p:sp>
@@ -8304,6 +8262,7 @@
           <a:lstStyle/>
           <a:p>
             <a:pPr algn="ctr"/>
+            <a:endParaRPr/>
           </a:p>
         </p:txBody>
       </p:sp>
@@ -8347,6 +8306,7 @@
           <a:lstStyle/>
           <a:p>
             <a:pPr algn="ctr"/>
+            <a:endParaRPr/>
           </a:p>
         </p:txBody>
       </p:sp>
@@ -8465,7 +8425,7 @@
 </file>
 
 <file path=ppt/slides/slide18.xml><?xml version="1.0" encoding="utf-8"?>
-<p:sld xmlns:a="http://schemas.openxmlformats.org/drawingml/2006/main" xmlns:p="http://schemas.openxmlformats.org/presentationml/2006/main" xmlns:r="http://schemas.openxmlformats.org/officeDocument/2006/relationships">
+<p:sld xmlns:a="http://schemas.openxmlformats.org/drawingml/2006/main" xmlns:r="http://schemas.openxmlformats.org/officeDocument/2006/relationships" xmlns:p="http://schemas.openxmlformats.org/presentationml/2006/main">
   <p:cSld>
     <p:spTree>
       <p:nvGrpSpPr>
@@ -8473,7 +8433,14 @@
         <p:cNvGrpSpPr/>
         <p:nvPr/>
       </p:nvGrpSpPr>
-      <p:grpSpPr/>
+      <p:grpSpPr>
+        <a:xfrm>
+          <a:off x="0" y="0"/>
+          <a:ext cx="0" cy="0"/>
+          <a:chOff x="0" y="0"/>
+          <a:chExt cx="0" cy="0"/>
+        </a:xfrm>
+      </p:grpSpPr>
       <p:sp>
         <p:nvSpPr>
           <p:cNvPr id="2" name="TextBox 1"/>
@@ -8548,6 +8515,7 @@
           <a:lstStyle/>
           <a:p>
             <a:pPr algn="ctr"/>
+            <a:endParaRPr/>
           </a:p>
         </p:txBody>
       </p:sp>
@@ -8591,6 +8559,7 @@
           <a:lstStyle/>
           <a:p>
             <a:pPr algn="ctr"/>
+            <a:endParaRPr/>
           </a:p>
         </p:txBody>
       </p:sp>
@@ -8660,6 +8629,7 @@
           <a:lstStyle/>
           <a:p>
             <a:pPr algn="ctr"/>
+            <a:endParaRPr/>
           </a:p>
         </p:txBody>
       </p:sp>
@@ -8703,6 +8673,7 @@
           <a:lstStyle/>
           <a:p>
             <a:pPr algn="ctr"/>
+            <a:endParaRPr/>
           </a:p>
         </p:txBody>
       </p:sp>
@@ -8819,6 +8790,7 @@
           <a:lstStyle/>
           <a:p>
             <a:pPr algn="ctr"/>
+            <a:endParaRPr/>
           </a:p>
         </p:txBody>
       </p:sp>
@@ -8862,6 +8834,7 @@
           <a:lstStyle/>
           <a:p>
             <a:pPr algn="ctr"/>
+            <a:endParaRPr/>
           </a:p>
         </p:txBody>
       </p:sp>
@@ -8980,7 +8953,7 @@
 </file>
 
 <file path=ppt/slides/slide19.xml><?xml version="1.0" encoding="utf-8"?>
-<p:sld xmlns:a="http://schemas.openxmlformats.org/drawingml/2006/main" xmlns:p="http://schemas.openxmlformats.org/presentationml/2006/main" xmlns:r="http://schemas.openxmlformats.org/officeDocument/2006/relationships">
+<p:sld xmlns:a="http://schemas.openxmlformats.org/drawingml/2006/main" xmlns:r="http://schemas.openxmlformats.org/officeDocument/2006/relationships" xmlns:p="http://schemas.openxmlformats.org/presentationml/2006/main" show="0">
   <p:cSld>
     <p:spTree>
       <p:nvGrpSpPr>
@@ -8988,7 +8961,14 @@
         <p:cNvGrpSpPr/>
         <p:nvPr/>
       </p:nvGrpSpPr>
-      <p:grpSpPr/>
+      <p:grpSpPr>
+        <a:xfrm>
+          <a:off x="0" y="0"/>
+          <a:ext cx="0" cy="0"/>
+          <a:chOff x="0" y="0"/>
+          <a:chExt cx="0" cy="0"/>
+        </a:xfrm>
+      </p:grpSpPr>
       <p:sp>
         <p:nvSpPr>
           <p:cNvPr id="2" name="TextBox 1"/>
@@ -9063,6 +9043,7 @@
           <a:lstStyle/>
           <a:p>
             <a:pPr algn="ctr"/>
+            <a:endParaRPr/>
           </a:p>
         </p:txBody>
       </p:sp>
@@ -9106,6 +9087,7 @@
           <a:lstStyle/>
           <a:p>
             <a:pPr algn="ctr"/>
+            <a:endParaRPr/>
           </a:p>
         </p:txBody>
       </p:sp>
@@ -9149,6 +9131,7 @@
           <a:lstStyle/>
           <a:p>
             <a:pPr algn="ctr"/>
+            <a:endParaRPr/>
           </a:p>
         </p:txBody>
       </p:sp>
@@ -9191,15 +9174,12 @@
           </a:p>
           <a:p>
             <a:pPr algn="l"/>
-            <a:r>
-              <a:rPr sz="1500" b="0">
-                <a:solidFill>
-                  <a:srgbClr val="1C1C1C"/>
-                </a:solidFill>
-                <a:latin typeface="Aptos Display"/>
-              </a:rPr>
-              <a:t/>
-            </a:r>
+            <a:endParaRPr sz="1500" b="1">
+              <a:solidFill>
+                <a:srgbClr val="1A5276"/>
+              </a:solidFill>
+              <a:latin typeface="Aptos Display"/>
+            </a:endParaRPr>
           </a:p>
           <a:p>
             <a:pPr algn="l">
@@ -9235,15 +9215,12 @@
           </a:p>
           <a:p>
             <a:pPr algn="l"/>
-            <a:r>
-              <a:rPr sz="1500" b="0">
-                <a:solidFill>
-                  <a:srgbClr val="1C1C1C"/>
-                </a:solidFill>
-                <a:latin typeface="Aptos Display"/>
-              </a:rPr>
-              <a:t/>
-            </a:r>
+            <a:endParaRPr sz="1500" b="0">
+              <a:solidFill>
+                <a:srgbClr val="1C1C1C"/>
+              </a:solidFill>
+              <a:latin typeface="Aptos Display"/>
+            </a:endParaRPr>
           </a:p>
           <a:p>
             <a:pPr algn="l">
@@ -9311,15 +9288,12 @@
           </a:p>
           <a:p>
             <a:pPr algn="l"/>
-            <a:r>
-              <a:rPr sz="1500" b="0">
-                <a:solidFill>
-                  <a:srgbClr val="1C1C1C"/>
-                </a:solidFill>
-                <a:latin typeface="Aptos Display"/>
-              </a:rPr>
-              <a:t/>
-            </a:r>
+            <a:endParaRPr sz="1500" b="0">
+              <a:solidFill>
+                <a:srgbClr val="1E8A44"/>
+              </a:solidFill>
+              <a:latin typeface="Aptos Display"/>
+            </a:endParaRPr>
           </a:p>
           <a:p>
             <a:pPr algn="l">
@@ -9379,6 +9353,7 @@
           <a:lstStyle/>
           <a:p>
             <a:pPr algn="ctr"/>
+            <a:endParaRPr/>
           </a:p>
         </p:txBody>
       </p:sp>
@@ -9421,15 +9396,12 @@
           </a:p>
           <a:p>
             <a:pPr algn="l"/>
-            <a:r>
-              <a:rPr sz="1500" b="0">
-                <a:solidFill>
-                  <a:srgbClr val="1C1C1C"/>
-                </a:solidFill>
-                <a:latin typeface="Aptos Display"/>
-              </a:rPr>
-              <a:t/>
-            </a:r>
+            <a:endParaRPr sz="1500" b="1">
+              <a:solidFill>
+                <a:srgbClr val="1A5276"/>
+              </a:solidFill>
+              <a:latin typeface="Aptos Display"/>
+            </a:endParaRPr>
           </a:p>
           <a:p>
             <a:pPr algn="l">
@@ -9481,15 +9453,12 @@
           </a:p>
           <a:p>
             <a:pPr algn="l"/>
-            <a:r>
-              <a:rPr sz="1500" b="0">
-                <a:solidFill>
-                  <a:srgbClr val="1C1C1C"/>
-                </a:solidFill>
-                <a:latin typeface="Aptos Display"/>
-              </a:rPr>
-              <a:t/>
-            </a:r>
+            <a:endParaRPr sz="1500" b="0">
+              <a:solidFill>
+                <a:srgbClr val="1C1C1C"/>
+              </a:solidFill>
+              <a:latin typeface="Aptos Display"/>
+            </a:endParaRPr>
           </a:p>
           <a:p>
             <a:pPr algn="l">
@@ -9509,15 +9478,12 @@
           </a:p>
           <a:p>
             <a:pPr algn="l"/>
-            <a:r>
-              <a:rPr sz="1500" b="0">
-                <a:solidFill>
-                  <a:srgbClr val="1C1C1C"/>
-                </a:solidFill>
-                <a:latin typeface="Aptos Display"/>
-              </a:rPr>
-              <a:t/>
-            </a:r>
+            <a:endParaRPr sz="1500" b="0">
+              <a:solidFill>
+                <a:srgbClr val="C0392B"/>
+              </a:solidFill>
+              <a:latin typeface="Aptos Display"/>
+            </a:endParaRPr>
           </a:p>
           <a:p>
             <a:pPr algn="l">
@@ -9613,7 +9579,7 @@
 </file>
 
 <file path=ppt/slides/slide2.xml><?xml version="1.0" encoding="utf-8"?>
-<p:sld xmlns:a="http://schemas.openxmlformats.org/drawingml/2006/main" xmlns:p="http://schemas.openxmlformats.org/presentationml/2006/main" xmlns:r="http://schemas.openxmlformats.org/officeDocument/2006/relationships">
+<p:sld xmlns:a="http://schemas.openxmlformats.org/drawingml/2006/main" xmlns:r="http://schemas.openxmlformats.org/officeDocument/2006/relationships" xmlns:p="http://schemas.openxmlformats.org/presentationml/2006/main">
   <p:cSld>
     <p:spTree>
       <p:nvGrpSpPr>
@@ -9621,7 +9587,14 @@
         <p:cNvGrpSpPr/>
         <p:nvPr/>
       </p:nvGrpSpPr>
-      <p:grpSpPr/>
+      <p:grpSpPr>
+        <a:xfrm>
+          <a:off x="0" y="0"/>
+          <a:ext cx="0" cy="0"/>
+          <a:chOff x="0" y="0"/>
+          <a:chExt cx="0" cy="0"/>
+        </a:xfrm>
+      </p:grpSpPr>
       <p:sp>
         <p:nvSpPr>
           <p:cNvPr id="2" name="TextBox 1"/>
@@ -9696,6 +9669,7 @@
           <a:lstStyle/>
           <a:p>
             <a:pPr algn="ctr"/>
+            <a:endParaRPr/>
           </a:p>
         </p:txBody>
       </p:sp>
@@ -9739,6 +9713,7 @@
           <a:lstStyle/>
           <a:p>
             <a:pPr algn="ctr"/>
+            <a:endParaRPr/>
           </a:p>
         </p:txBody>
       </p:sp>
@@ -9782,6 +9757,7 @@
           <a:lstStyle/>
           <a:p>
             <a:pPr algn="ctr"/>
+            <a:endParaRPr/>
           </a:p>
         </p:txBody>
       </p:sp>
@@ -9825,6 +9801,7 @@
           <a:lstStyle/>
           <a:p>
             <a:pPr algn="ctr"/>
+            <a:endParaRPr/>
           </a:p>
         </p:txBody>
       </p:sp>
@@ -9938,6 +9915,7 @@
           <a:lstStyle/>
           <a:p>
             <a:pPr algn="ctr"/>
+            <a:endParaRPr/>
           </a:p>
         </p:txBody>
       </p:sp>
@@ -9981,6 +9959,7 @@
           <a:lstStyle/>
           <a:p>
             <a:pPr algn="ctr"/>
+            <a:endParaRPr/>
           </a:p>
         </p:txBody>
       </p:sp>
@@ -10094,6 +10073,7 @@
           <a:lstStyle/>
           <a:p>
             <a:pPr algn="ctr"/>
+            <a:endParaRPr/>
           </a:p>
         </p:txBody>
       </p:sp>
@@ -10137,6 +10117,7 @@
           <a:lstStyle/>
           <a:p>
             <a:pPr algn="ctr"/>
+            <a:endParaRPr/>
           </a:p>
         </p:txBody>
       </p:sp>
@@ -10250,6 +10231,7 @@
           <a:lstStyle/>
           <a:p>
             <a:pPr algn="ctr"/>
+            <a:endParaRPr/>
           </a:p>
         </p:txBody>
       </p:sp>
@@ -10293,6 +10275,7 @@
           <a:lstStyle/>
           <a:p>
             <a:pPr algn="ctr"/>
+            <a:endParaRPr/>
           </a:p>
         </p:txBody>
       </p:sp>
@@ -10410,7 +10393,7 @@
 </file>
 
 <file path=ppt/slides/slide20.xml><?xml version="1.0" encoding="utf-8"?>
-<p:sld xmlns:a="http://schemas.openxmlformats.org/drawingml/2006/main" xmlns:p="http://schemas.openxmlformats.org/presentationml/2006/main" xmlns:r="http://schemas.openxmlformats.org/officeDocument/2006/relationships">
+<p:sld xmlns:a="http://schemas.openxmlformats.org/drawingml/2006/main" xmlns:r="http://schemas.openxmlformats.org/officeDocument/2006/relationships" xmlns:p="http://schemas.openxmlformats.org/presentationml/2006/main">
   <p:cSld>
     <p:spTree>
       <p:nvGrpSpPr>
@@ -10418,7 +10401,14 @@
         <p:cNvGrpSpPr/>
         <p:nvPr/>
       </p:nvGrpSpPr>
-      <p:grpSpPr/>
+      <p:grpSpPr>
+        <a:xfrm>
+          <a:off x="0" y="0"/>
+          <a:ext cx="0" cy="0"/>
+          <a:chOff x="0" y="0"/>
+          <a:chExt cx="0" cy="0"/>
+        </a:xfrm>
+      </p:grpSpPr>
       <p:sp>
         <p:nvSpPr>
           <p:cNvPr id="2" name="TextBox 1"/>
@@ -10493,6 +10483,7 @@
           <a:lstStyle/>
           <a:p>
             <a:pPr algn="ctr"/>
+            <a:endParaRPr/>
           </a:p>
         </p:txBody>
       </p:sp>
@@ -10536,6 +10527,7 @@
           <a:lstStyle/>
           <a:p>
             <a:pPr algn="ctr"/>
+            <a:endParaRPr/>
           </a:p>
         </p:txBody>
       </p:sp>
@@ -10547,7 +10539,7 @@
         </p:nvSpPr>
         <p:spPr>
           <a:xfrm>
-            <a:off x="720000" y="2008800"/>
+            <a:off x="2145677" y="2008800"/>
             <a:ext cx="2526299" cy="3733200"/>
           </a:xfrm>
           <a:prstGeom prst="roundRect">
@@ -10581,6 +10573,7 @@
           <a:lstStyle/>
           <a:p>
             <a:pPr algn="ctr"/>
+            <a:endParaRPr/>
           </a:p>
         </p:txBody>
       </p:sp>
@@ -10592,7 +10585,7 @@
         </p:nvSpPr>
         <p:spPr>
           <a:xfrm>
-            <a:off x="720000" y="2008800"/>
+            <a:off x="2145677" y="2008800"/>
             <a:ext cx="2526299" cy="79200"/>
           </a:xfrm>
           <a:prstGeom prst="rect">
@@ -10624,6 +10617,7 @@
           <a:lstStyle/>
           <a:p>
             <a:pPr algn="ctr"/>
+            <a:endParaRPr/>
           </a:p>
         </p:txBody>
       </p:sp>
@@ -10635,7 +10629,7 @@
         </p:nvSpPr>
         <p:spPr>
           <a:xfrm>
-            <a:off x="864000" y="2531448"/>
+            <a:off x="2289677" y="2531448"/>
             <a:ext cx="2238300" cy="1717272"/>
           </a:xfrm>
           <a:prstGeom prst="rect">
@@ -10670,7 +10664,7 @@
         </p:nvSpPr>
         <p:spPr>
           <a:xfrm>
-            <a:off x="864000" y="4323384"/>
+            <a:off x="2289677" y="4323384"/>
             <a:ext cx="2238300" cy="1231956"/>
           </a:xfrm>
           <a:prstGeom prst="rect">
@@ -10705,7 +10699,7 @@
         </p:nvSpPr>
         <p:spPr>
           <a:xfrm>
-            <a:off x="3462300" y="2008800"/>
+            <a:off x="4887977" y="2008800"/>
             <a:ext cx="2526299" cy="3733200"/>
           </a:xfrm>
           <a:prstGeom prst="roundRect">
@@ -10739,6 +10733,7 @@
           <a:lstStyle/>
           <a:p>
             <a:pPr algn="ctr"/>
+            <a:endParaRPr/>
           </a:p>
         </p:txBody>
       </p:sp>
@@ -10750,7 +10745,7 @@
         </p:nvSpPr>
         <p:spPr>
           <a:xfrm>
-            <a:off x="3462300" y="2008800"/>
+            <a:off x="4887977" y="2008800"/>
             <a:ext cx="2526299" cy="79200"/>
           </a:xfrm>
           <a:prstGeom prst="rect">
@@ -10782,6 +10777,7 @@
           <a:lstStyle/>
           <a:p>
             <a:pPr algn="ctr"/>
+            <a:endParaRPr/>
           </a:p>
         </p:txBody>
       </p:sp>
@@ -10793,7 +10789,7 @@
         </p:nvSpPr>
         <p:spPr>
           <a:xfrm>
-            <a:off x="3606300" y="2531448"/>
+            <a:off x="5031977" y="2531448"/>
             <a:ext cx="2238300" cy="1717272"/>
           </a:xfrm>
           <a:prstGeom prst="rect">
@@ -10828,7 +10824,7 @@
         </p:nvSpPr>
         <p:spPr>
           <a:xfrm>
-            <a:off x="3606300" y="4323384"/>
+            <a:off x="5031977" y="4323384"/>
             <a:ext cx="2238300" cy="1231956"/>
           </a:xfrm>
           <a:prstGeom prst="rect">
@@ -10863,7 +10859,7 @@
         </p:nvSpPr>
         <p:spPr>
           <a:xfrm>
-            <a:off x="6204600" y="2008800"/>
+            <a:off x="7630277" y="2008800"/>
             <a:ext cx="2526299" cy="3733200"/>
           </a:xfrm>
           <a:prstGeom prst="roundRect">
@@ -10897,6 +10893,7 @@
           <a:lstStyle/>
           <a:p>
             <a:pPr algn="ctr"/>
+            <a:endParaRPr/>
           </a:p>
         </p:txBody>
       </p:sp>
@@ -10908,7 +10905,7 @@
         </p:nvSpPr>
         <p:spPr>
           <a:xfrm>
-            <a:off x="6204600" y="2008800"/>
+            <a:off x="7630277" y="2008800"/>
             <a:ext cx="2526299" cy="79200"/>
           </a:xfrm>
           <a:prstGeom prst="rect">
@@ -10940,6 +10937,7 @@
           <a:lstStyle/>
           <a:p>
             <a:pPr algn="ctr"/>
+            <a:endParaRPr/>
           </a:p>
         </p:txBody>
       </p:sp>
@@ -10951,7 +10949,7 @@
         </p:nvSpPr>
         <p:spPr>
           <a:xfrm>
-            <a:off x="6348599" y="2531448"/>
+            <a:off x="7774276" y="2531448"/>
             <a:ext cx="2238300" cy="1717272"/>
           </a:xfrm>
           <a:prstGeom prst="rect">
@@ -10986,7 +10984,7 @@
         </p:nvSpPr>
         <p:spPr>
           <a:xfrm>
-            <a:off x="6348599" y="4323384"/>
+            <a:off x="7774276" y="4323384"/>
             <a:ext cx="2238300" cy="1231956"/>
           </a:xfrm>
           <a:prstGeom prst="rect">
@@ -11009,164 +11007,6 @@
                 <a:latin typeface="Aptos Display"/>
               </a:rPr>
               <a:t>AUC-ROC</a:t>
-            </a:r>
-          </a:p>
-        </p:txBody>
-      </p:sp>
-      <p:sp>
-        <p:nvSpPr>
-          <p:cNvPr id="17" name="Rounded Rectangle 16"/>
-          <p:cNvSpPr/>
-          <p:nvPr/>
-        </p:nvSpPr>
-        <p:spPr>
-          <a:xfrm>
-            <a:off x="8946899" y="2008800"/>
-            <a:ext cx="2526299" cy="3733200"/>
-          </a:xfrm>
-          <a:prstGeom prst="roundRect">
-            <a:avLst>
-              <a:gd name="adj" fmla="val 10000"/>
-            </a:avLst>
-          </a:prstGeom>
-          <a:solidFill>
-            <a:srgbClr val="F2F2F2"/>
-          </a:solidFill>
-          <a:ln>
-            <a:noFill/>
-          </a:ln>
-        </p:spPr>
-        <p:style>
-          <a:lnRef idx="1">
-            <a:schemeClr val="accent1"/>
-          </a:lnRef>
-          <a:fillRef idx="3">
-            <a:schemeClr val="accent1"/>
-          </a:fillRef>
-          <a:effectRef idx="2">
-            <a:schemeClr val="accent1"/>
-          </a:effectRef>
-          <a:fontRef idx="minor">
-            <a:schemeClr val="lt1"/>
-          </a:fontRef>
-        </p:style>
-        <p:txBody>
-          <a:bodyPr rtlCol="0" anchor="ctr"/>
-          <a:lstStyle/>
-          <a:p>
-            <a:pPr algn="ctr"/>
-          </a:p>
-        </p:txBody>
-      </p:sp>
-      <p:sp>
-        <p:nvSpPr>
-          <p:cNvPr id="18" name="Rectangle 17"/>
-          <p:cNvSpPr/>
-          <p:nvPr/>
-        </p:nvSpPr>
-        <p:spPr>
-          <a:xfrm>
-            <a:off x="8946899" y="2008800"/>
-            <a:ext cx="2526299" cy="79200"/>
-          </a:xfrm>
-          <a:prstGeom prst="rect">
-            <a:avLst/>
-          </a:prstGeom>
-          <a:solidFill>
-            <a:srgbClr val="2E86C1"/>
-          </a:solidFill>
-          <a:ln>
-            <a:noFill/>
-          </a:ln>
-        </p:spPr>
-        <p:style>
-          <a:lnRef idx="1">
-            <a:schemeClr val="accent1"/>
-          </a:lnRef>
-          <a:fillRef idx="3">
-            <a:schemeClr val="accent1"/>
-          </a:fillRef>
-          <a:effectRef idx="2">
-            <a:schemeClr val="accent1"/>
-          </a:effectRef>
-          <a:fontRef idx="minor">
-            <a:schemeClr val="lt1"/>
-          </a:fontRef>
-        </p:style>
-        <p:txBody>
-          <a:bodyPr rtlCol="0" anchor="ctr"/>
-          <a:lstStyle/>
-          <a:p>
-            <a:pPr algn="ctr"/>
-          </a:p>
-        </p:txBody>
-      </p:sp>
-      <p:sp>
-        <p:nvSpPr>
-          <p:cNvPr id="19" name="TextBox 18"/>
-          <p:cNvSpPr txBox="1"/>
-          <p:nvPr/>
-        </p:nvSpPr>
-        <p:spPr>
-          <a:xfrm>
-            <a:off x="9090899" y="2531448"/>
-            <a:ext cx="2238300" cy="1717272"/>
-          </a:xfrm>
-          <a:prstGeom prst="rect">
-            <a:avLst/>
-          </a:prstGeom>
-          <a:noFill/>
-        </p:spPr>
-        <p:txBody>
-          <a:bodyPr wrap="square">
-            <a:spAutoFit/>
-          </a:bodyPr>
-          <a:lstStyle/>
-          <a:p>
-            <a:pPr algn="ctr"/>
-            <a:r>
-              <a:rPr sz="4000" b="1">
-                <a:solidFill>
-                  <a:srgbClr val="2E86C1"/>
-                </a:solidFill>
-                <a:latin typeface="Aptos Display"/>
-              </a:rPr>
-              <a:t>2 modes</a:t>
-            </a:r>
-          </a:p>
-        </p:txBody>
-      </p:sp>
-      <p:sp>
-        <p:nvSpPr>
-          <p:cNvPr id="20" name="TextBox 19"/>
-          <p:cNvSpPr txBox="1"/>
-          <p:nvPr/>
-        </p:nvSpPr>
-        <p:spPr>
-          <a:xfrm>
-            <a:off x="9090899" y="4323384"/>
-            <a:ext cx="2238300" cy="1231956"/>
-          </a:xfrm>
-          <a:prstGeom prst="rect">
-            <a:avLst/>
-          </a:prstGeom>
-          <a:noFill/>
-        </p:spPr>
-        <p:txBody>
-          <a:bodyPr wrap="square">
-            <a:spAutoFit/>
-          </a:bodyPr>
-          <a:lstStyle/>
-          <a:p>
-            <a:pPr algn="ctr"/>
-            <a:r>
-              <a:rPr sz="1300" b="0">
-                <a:solidFill>
-                  <a:srgbClr val="888888"/>
-                </a:solidFill>
-                <a:latin typeface="Aptos Display"/>
-              </a:rPr>
-              <a:t>CSV ou valeurs directes</a:t>
             </a:r>
           </a:p>
         </p:txBody>
@@ -11250,7 +11090,7 @@
 </file>
 
 <file path=ppt/slides/slide3.xml><?xml version="1.0" encoding="utf-8"?>
-<p:sld xmlns:a="http://schemas.openxmlformats.org/drawingml/2006/main" xmlns:p="http://schemas.openxmlformats.org/presentationml/2006/main" xmlns:r="http://schemas.openxmlformats.org/officeDocument/2006/relationships">
+<p:sld xmlns:a="http://schemas.openxmlformats.org/drawingml/2006/main" xmlns:r="http://schemas.openxmlformats.org/officeDocument/2006/relationships" xmlns:p="http://schemas.openxmlformats.org/presentationml/2006/main">
   <p:cSld>
     <p:spTree>
       <p:nvGrpSpPr>
@@ -11258,7 +11098,14 @@
         <p:cNvGrpSpPr/>
         <p:nvPr/>
       </p:nvGrpSpPr>
-      <p:grpSpPr/>
+      <p:grpSpPr>
+        <a:xfrm>
+          <a:off x="0" y="0"/>
+          <a:ext cx="0" cy="0"/>
+          <a:chOff x="0" y="0"/>
+          <a:chExt cx="0" cy="0"/>
+        </a:xfrm>
+      </p:grpSpPr>
       <p:sp>
         <p:nvSpPr>
           <p:cNvPr id="2" name="Rectangle 1"/>
@@ -11299,6 +11146,7 @@
           <a:lstStyle/>
           <a:p>
             <a:pPr algn="ctr"/>
+            <a:endParaRPr/>
           </a:p>
         </p:txBody>
       </p:sp>
@@ -11416,7 +11264,7 @@
 </file>
 
 <file path=ppt/slides/slide4.xml><?xml version="1.0" encoding="utf-8"?>
-<p:sld xmlns:a="http://schemas.openxmlformats.org/drawingml/2006/main" xmlns:p="http://schemas.openxmlformats.org/presentationml/2006/main" xmlns:r="http://schemas.openxmlformats.org/officeDocument/2006/relationships">
+<p:sld xmlns:a="http://schemas.openxmlformats.org/drawingml/2006/main" xmlns:r="http://schemas.openxmlformats.org/officeDocument/2006/relationships" xmlns:p="http://schemas.openxmlformats.org/presentationml/2006/main">
   <p:cSld>
     <p:spTree>
       <p:nvGrpSpPr>
@@ -11424,7 +11272,14 @@
         <p:cNvGrpSpPr/>
         <p:nvPr/>
       </p:nvGrpSpPr>
-      <p:grpSpPr/>
+      <p:grpSpPr>
+        <a:xfrm>
+          <a:off x="0" y="0"/>
+          <a:ext cx="0" cy="0"/>
+          <a:chOff x="0" y="0"/>
+          <a:chExt cx="0" cy="0"/>
+        </a:xfrm>
+      </p:grpSpPr>
       <p:sp>
         <p:nvSpPr>
           <p:cNvPr id="2" name="TextBox 1"/>
@@ -11499,6 +11354,7 @@
           <a:lstStyle/>
           <a:p>
             <a:pPr algn="ctr"/>
+            <a:endParaRPr/>
           </a:p>
         </p:txBody>
       </p:sp>
@@ -11542,6 +11398,7 @@
           <a:lstStyle/>
           <a:p>
             <a:pPr algn="ctr"/>
+            <a:endParaRPr/>
           </a:p>
         </p:txBody>
       </p:sp>
@@ -11611,6 +11468,7 @@
           <a:lstStyle/>
           <a:p>
             <a:pPr algn="ctr"/>
+            <a:endParaRPr/>
           </a:p>
         </p:txBody>
       </p:sp>
@@ -11654,6 +11512,7 @@
           <a:lstStyle/>
           <a:p>
             <a:pPr algn="ctr"/>
+            <a:endParaRPr/>
           </a:p>
         </p:txBody>
       </p:sp>
@@ -11769,6 +11628,7 @@
           <a:lstStyle/>
           <a:p>
             <a:pPr algn="ctr"/>
+            <a:endParaRPr/>
           </a:p>
         </p:txBody>
       </p:sp>
@@ -11812,6 +11672,7 @@
           <a:lstStyle/>
           <a:p>
             <a:pPr algn="ctr"/>
+            <a:endParaRPr/>
           </a:p>
         </p:txBody>
       </p:sp>
@@ -11927,6 +11788,7 @@
           <a:lstStyle/>
           <a:p>
             <a:pPr algn="ctr"/>
+            <a:endParaRPr/>
           </a:p>
         </p:txBody>
       </p:sp>
@@ -11970,6 +11832,7 @@
           <a:lstStyle/>
           <a:p>
             <a:pPr algn="ctr"/>
+            <a:endParaRPr/>
           </a:p>
         </p:txBody>
       </p:sp>
@@ -12087,7 +11950,7 @@
 </file>
 
 <file path=ppt/slides/slide5.xml><?xml version="1.0" encoding="utf-8"?>
-<p:sld xmlns:a="http://schemas.openxmlformats.org/drawingml/2006/main" xmlns:p="http://schemas.openxmlformats.org/presentationml/2006/main" xmlns:r="http://schemas.openxmlformats.org/officeDocument/2006/relationships">
+<p:sld xmlns:a="http://schemas.openxmlformats.org/drawingml/2006/main" xmlns:r="http://schemas.openxmlformats.org/officeDocument/2006/relationships" xmlns:p="http://schemas.openxmlformats.org/presentationml/2006/main">
   <p:cSld>
     <p:spTree>
       <p:nvGrpSpPr>
@@ -12095,7 +11958,14 @@
         <p:cNvGrpSpPr/>
         <p:nvPr/>
       </p:nvGrpSpPr>
-      <p:grpSpPr/>
+      <p:grpSpPr>
+        <a:xfrm>
+          <a:off x="0" y="0"/>
+          <a:ext cx="0" cy="0"/>
+          <a:chOff x="0" y="0"/>
+          <a:chExt cx="0" cy="0"/>
+        </a:xfrm>
+      </p:grpSpPr>
       <p:sp>
         <p:nvSpPr>
           <p:cNvPr id="2" name="TextBox 1"/>
@@ -12105,7 +11975,7 @@
         <p:spPr>
           <a:xfrm>
             <a:off x="720000" y="216000"/>
-            <a:ext cx="10753200" cy="1116000"/>
+            <a:ext cx="10753200" cy="646331"/>
           </a:xfrm>
           <a:prstGeom prst="rect">
             <a:avLst/>
@@ -12119,13 +11989,76 @@
           <a:lstStyle/>
           <a:p>
             <a:r>
-              <a:rPr sz="3600" b="1">
+              <a:rPr sz="3600" b="1" dirty="0" err="1">
                 <a:solidFill>
                   <a:srgbClr val="1C1C1C"/>
                 </a:solidFill>
                 <a:latin typeface="Aptos Display"/>
               </a:rPr>
-              <a:t>Pairplot : margin_low et length séparent clairement les deux classes</a:t>
+              <a:t>Pairplot</a:t>
+            </a:r>
+            <a:r>
+              <a:rPr sz="3600" b="1" dirty="0">
+                <a:solidFill>
+                  <a:srgbClr val="1C1C1C"/>
+                </a:solidFill>
+                <a:latin typeface="Aptos Display"/>
+              </a:rPr>
+              <a:t> : </a:t>
+            </a:r>
+            <a:r>
+              <a:rPr sz="3600" b="1" dirty="0" err="1">
+                <a:solidFill>
+                  <a:srgbClr val="1C1C1C"/>
+                </a:solidFill>
+                <a:latin typeface="Aptos Display"/>
+              </a:rPr>
+              <a:t>margin_low</a:t>
+            </a:r>
+            <a:r>
+              <a:rPr sz="3600" b="1" dirty="0">
+                <a:solidFill>
+                  <a:srgbClr val="1C1C1C"/>
+                </a:solidFill>
+                <a:latin typeface="Aptos Display"/>
+              </a:rPr>
+              <a:t> et length </a:t>
+            </a:r>
+            <a:r>
+              <a:rPr sz="3600" b="1" dirty="0" err="1">
+                <a:solidFill>
+                  <a:srgbClr val="1C1C1C"/>
+                </a:solidFill>
+                <a:latin typeface="Aptos Display"/>
+              </a:rPr>
+              <a:t>séparent</a:t>
+            </a:r>
+            <a:r>
+              <a:rPr sz="3600" b="1" dirty="0">
+                <a:solidFill>
+                  <a:srgbClr val="1C1C1C"/>
+                </a:solidFill>
+                <a:latin typeface="Aptos Display"/>
+              </a:rPr>
+              <a:t> les </a:t>
+            </a:r>
+            <a:r>
+              <a:rPr lang="fr-FR" sz="3600" b="1" dirty="0">
+                <a:solidFill>
+                  <a:srgbClr val="1C1C1C"/>
+                </a:solidFill>
+                <a:latin typeface="Aptos Display"/>
+              </a:rPr>
+              <a:t>2</a:t>
+            </a:r>
+            <a:r>
+              <a:rPr sz="3600" b="1" dirty="0">
+                <a:solidFill>
+                  <a:srgbClr val="1C1C1C"/>
+                </a:solidFill>
+                <a:latin typeface="Aptos Display"/>
+              </a:rPr>
+              <a:t> classes</a:t>
             </a:r>
           </a:p>
         </p:txBody>
@@ -12138,7 +12071,7 @@
         </p:nvSpPr>
         <p:spPr>
           <a:xfrm>
-            <a:off x="720000" y="1620000"/>
+            <a:off x="720000" y="952776"/>
             <a:ext cx="10753200" cy="28800"/>
           </a:xfrm>
           <a:prstGeom prst="rect">
@@ -12170,6 +12103,7 @@
           <a:lstStyle/>
           <a:p>
             <a:pPr algn="ctr"/>
+            <a:endParaRPr/>
           </a:p>
         </p:txBody>
       </p:sp>
@@ -12213,6 +12147,7 @@
           <a:lstStyle/>
           <a:p>
             <a:pPr algn="ctr"/>
+            <a:endParaRPr/>
           </a:p>
         </p:txBody>
       </p:sp>
@@ -12232,8 +12167,8 @@
         </p:blipFill>
         <p:spPr>
           <a:xfrm>
-            <a:off x="1915294" y="2008800"/>
-            <a:ext cx="4709331" cy="4489200"/>
+            <a:off x="684023" y="1153745"/>
+            <a:ext cx="6639072" cy="5596255"/>
           </a:xfrm>
           <a:prstGeom prst="rect">
             <a:avLst/>
@@ -12282,6 +12217,7 @@
           <a:lstStyle/>
           <a:p>
             <a:pPr algn="ctr"/>
+            <a:endParaRPr/>
           </a:p>
         </p:txBody>
       </p:sp>
@@ -12325,6 +12261,7 @@
           <a:lstStyle/>
           <a:p>
             <a:pPr algn="ctr"/>
+            <a:endParaRPr/>
           </a:p>
         </p:txBody>
       </p:sp>
@@ -12440,6 +12377,7 @@
           <a:lstStyle/>
           <a:p>
             <a:pPr algn="ctr"/>
+            <a:endParaRPr/>
           </a:p>
         </p:txBody>
       </p:sp>
@@ -12483,6 +12421,7 @@
           <a:lstStyle/>
           <a:p>
             <a:pPr algn="ctr"/>
+            <a:endParaRPr/>
           </a:p>
         </p:txBody>
       </p:sp>
@@ -12598,6 +12537,7 @@
           <a:lstStyle/>
           <a:p>
             <a:pPr algn="ctr"/>
+            <a:endParaRPr/>
           </a:p>
         </p:txBody>
       </p:sp>
@@ -12641,6 +12581,7 @@
           <a:lstStyle/>
           <a:p>
             <a:pPr algn="ctr"/>
+            <a:endParaRPr/>
           </a:p>
         </p:txBody>
       </p:sp>
@@ -12758,7 +12699,7 @@
 </file>
 
 <file path=ppt/slides/slide6.xml><?xml version="1.0" encoding="utf-8"?>
-<p:sld xmlns:a="http://schemas.openxmlformats.org/drawingml/2006/main" xmlns:p="http://schemas.openxmlformats.org/presentationml/2006/main" xmlns:r="http://schemas.openxmlformats.org/officeDocument/2006/relationships">
+<p:sld xmlns:a="http://schemas.openxmlformats.org/drawingml/2006/main" xmlns:r="http://schemas.openxmlformats.org/officeDocument/2006/relationships" xmlns:p="http://schemas.openxmlformats.org/presentationml/2006/main">
   <p:cSld>
     <p:spTree>
       <p:nvGrpSpPr>
@@ -12766,7 +12707,14 @@
         <p:cNvGrpSpPr/>
         <p:nvPr/>
       </p:nvGrpSpPr>
-      <p:grpSpPr/>
+      <p:grpSpPr>
+        <a:xfrm>
+          <a:off x="0" y="0"/>
+          <a:ext cx="0" cy="0"/>
+          <a:chOff x="0" y="0"/>
+          <a:chExt cx="0" cy="0"/>
+        </a:xfrm>
+      </p:grpSpPr>
       <p:sp>
         <p:nvSpPr>
           <p:cNvPr id="2" name="TextBox 1"/>
@@ -12841,6 +12789,7 @@
           <a:lstStyle/>
           <a:p>
             <a:pPr algn="ctr"/>
+            <a:endParaRPr/>
           </a:p>
         </p:txBody>
       </p:sp>
@@ -12884,6 +12833,7 @@
           <a:lstStyle/>
           <a:p>
             <a:pPr algn="ctr"/>
+            <a:endParaRPr/>
           </a:p>
         </p:txBody>
       </p:sp>
@@ -12903,8 +12853,8 @@
         </p:blipFill>
         <p:spPr>
           <a:xfrm>
-            <a:off x="1519648" y="2008800"/>
-            <a:ext cx="5500622" cy="4489200"/>
+            <a:off x="1213239" y="2008800"/>
+            <a:ext cx="5807031" cy="4739268"/>
           </a:xfrm>
           <a:prstGeom prst="rect">
             <a:avLst/>
@@ -12953,6 +12903,7 @@
           <a:lstStyle/>
           <a:p>
             <a:pPr algn="ctr"/>
+            <a:endParaRPr/>
           </a:p>
         </p:txBody>
       </p:sp>
@@ -12996,6 +12947,7 @@
           <a:lstStyle/>
           <a:p>
             <a:pPr algn="ctr"/>
+            <a:endParaRPr/>
           </a:p>
         </p:txBody>
       </p:sp>
@@ -13111,6 +13063,7 @@
           <a:lstStyle/>
           <a:p>
             <a:pPr algn="ctr"/>
+            <a:endParaRPr/>
           </a:p>
         </p:txBody>
       </p:sp>
@@ -13154,6 +13107,7 @@
           <a:lstStyle/>
           <a:p>
             <a:pPr algn="ctr"/>
+            <a:endParaRPr/>
           </a:p>
         </p:txBody>
       </p:sp>
@@ -13165,8 +13119,8 @@
         </p:nvSpPr>
         <p:spPr>
           <a:xfrm>
-            <a:off x="8107919" y="4676004"/>
-            <a:ext cx="3221280" cy="974556"/>
+            <a:off x="8107918" y="4676004"/>
+            <a:ext cx="3293281" cy="707886"/>
           </a:xfrm>
           <a:prstGeom prst="rect">
             <a:avLst/>
@@ -13181,14 +13135,40 @@
           <a:p>
             <a:pPr algn="ctr"/>
             <a:r>
-              <a:rPr sz="4000" b="1">
+              <a:rPr sz="4000" b="1" dirty="0" err="1">
                 <a:solidFill>
                   <a:srgbClr val="2E86C1"/>
                 </a:solidFill>
                 <a:latin typeface="Aptos Display"/>
               </a:rPr>
-              <a:t>Rég.
-lin.</a:t>
+              <a:t>Rég</a:t>
+            </a:r>
+            <a:r>
+              <a:rPr sz="4000" b="1" dirty="0">
+                <a:solidFill>
+                  <a:srgbClr val="2E86C1"/>
+                </a:solidFill>
+                <a:latin typeface="Aptos Display"/>
+              </a:rPr>
+              <a:t>.</a:t>
+            </a:r>
+            <a:r>
+              <a:rPr lang="fr-FR" sz="4000" b="1" dirty="0">
+                <a:solidFill>
+                  <a:srgbClr val="2E86C1"/>
+                </a:solidFill>
+                <a:latin typeface="Aptos Display"/>
+              </a:rPr>
+              <a:t> </a:t>
+            </a:r>
+            <a:r>
+              <a:rPr sz="4000" b="1" dirty="0">
+                <a:solidFill>
+                  <a:srgbClr val="2E86C1"/>
+                </a:solidFill>
+                <a:latin typeface="Aptos Display"/>
+              </a:rPr>
+              <a:t>lin.</a:t>
             </a:r>
           </a:p>
         </p:txBody>
@@ -13272,7 +13252,7 @@
 </file>
 
 <file path=ppt/slides/slide7.xml><?xml version="1.0" encoding="utf-8"?>
-<p:sld xmlns:a="http://schemas.openxmlformats.org/drawingml/2006/main" xmlns:p="http://schemas.openxmlformats.org/presentationml/2006/main" xmlns:r="http://schemas.openxmlformats.org/officeDocument/2006/relationships">
+<p:sld xmlns:a="http://schemas.openxmlformats.org/drawingml/2006/main" xmlns:r="http://schemas.openxmlformats.org/officeDocument/2006/relationships" xmlns:p="http://schemas.openxmlformats.org/presentationml/2006/main">
   <p:cSld>
     <p:spTree>
       <p:nvGrpSpPr>
@@ -13280,7 +13260,14 @@
         <p:cNvGrpSpPr/>
         <p:nvPr/>
       </p:nvGrpSpPr>
-      <p:grpSpPr/>
+      <p:grpSpPr>
+        <a:xfrm>
+          <a:off x="0" y="0"/>
+          <a:ext cx="0" cy="0"/>
+          <a:chOff x="0" y="0"/>
+          <a:chExt cx="0" cy="0"/>
+        </a:xfrm>
+      </p:grpSpPr>
       <p:sp>
         <p:nvSpPr>
           <p:cNvPr id="2" name="Rectangle 1"/>
@@ -13321,6 +13308,7 @@
           <a:lstStyle/>
           <a:p>
             <a:pPr algn="ctr"/>
+            <a:endParaRPr/>
           </a:p>
         </p:txBody>
       </p:sp>
@@ -13438,7 +13426,7 @@
 </file>
 
 <file path=ppt/slides/slide8.xml><?xml version="1.0" encoding="utf-8"?>
-<p:sld xmlns:a="http://schemas.openxmlformats.org/drawingml/2006/main" xmlns:p="http://schemas.openxmlformats.org/presentationml/2006/main" xmlns:r="http://schemas.openxmlformats.org/officeDocument/2006/relationships">
+<p:sld xmlns:a="http://schemas.openxmlformats.org/drawingml/2006/main" xmlns:r="http://schemas.openxmlformats.org/officeDocument/2006/relationships" xmlns:p="http://schemas.openxmlformats.org/presentationml/2006/main">
   <p:cSld>
     <p:spTree>
       <p:nvGrpSpPr>
@@ -13446,7 +13434,14 @@
         <p:cNvGrpSpPr/>
         <p:nvPr/>
       </p:nvGrpSpPr>
-      <p:grpSpPr/>
+      <p:grpSpPr>
+        <a:xfrm>
+          <a:off x="0" y="0"/>
+          <a:ext cx="0" cy="0"/>
+          <a:chOff x="0" y="0"/>
+          <a:chExt cx="0" cy="0"/>
+        </a:xfrm>
+      </p:grpSpPr>
       <p:sp>
         <p:nvSpPr>
           <p:cNvPr id="2" name="TextBox 1"/>
@@ -13521,6 +13516,7 @@
           <a:lstStyle/>
           <a:p>
             <a:pPr algn="ctr"/>
+            <a:endParaRPr/>
           </a:p>
         </p:txBody>
       </p:sp>
@@ -13564,6 +13560,7 @@
           <a:lstStyle/>
           <a:p>
             <a:pPr algn="ctr"/>
+            <a:endParaRPr/>
           </a:p>
         </p:txBody>
       </p:sp>
@@ -13607,6 +13604,7 @@
           <a:lstStyle/>
           <a:p>
             <a:pPr algn="ctr"/>
+            <a:endParaRPr/>
           </a:p>
         </p:txBody>
       </p:sp>
@@ -13650,6 +13648,7 @@
           <a:lstStyle/>
           <a:p>
             <a:pPr algn="ctr"/>
+            <a:endParaRPr/>
           </a:p>
         </p:txBody>
       </p:sp>
@@ -13764,6 +13763,7 @@
           <a:lstStyle/>
           <a:p>
             <a:pPr algn="ctr"/>
+            <a:endParaRPr/>
           </a:p>
         </p:txBody>
       </p:sp>
@@ -13807,6 +13807,7 @@
           <a:lstStyle/>
           <a:p>
             <a:pPr algn="ctr"/>
+            <a:endParaRPr/>
           </a:p>
         </p:txBody>
       </p:sp>
@@ -13920,6 +13921,7 @@
           <a:lstStyle/>
           <a:p>
             <a:pPr algn="ctr"/>
+            <a:endParaRPr/>
           </a:p>
         </p:txBody>
       </p:sp>
@@ -13963,6 +13965,7 @@
           <a:lstStyle/>
           <a:p>
             <a:pPr algn="ctr"/>
+            <a:endParaRPr/>
           </a:p>
         </p:txBody>
       </p:sp>
@@ -14079,6 +14082,7 @@
           <a:lstStyle/>
           <a:p>
             <a:pPr algn="ctr"/>
+            <a:endParaRPr/>
           </a:p>
         </p:txBody>
       </p:sp>
@@ -14122,6 +14126,7 @@
           <a:lstStyle/>
           <a:p>
             <a:pPr algn="ctr"/>
+            <a:endParaRPr/>
           </a:p>
         </p:txBody>
       </p:sp>
@@ -14242,7 +14247,7 @@
 </file>
 
 <file path=ppt/slides/slide9.xml><?xml version="1.0" encoding="utf-8"?>
-<p:sld xmlns:a="http://schemas.openxmlformats.org/drawingml/2006/main" xmlns:p="http://schemas.openxmlformats.org/presentationml/2006/main" xmlns:r="http://schemas.openxmlformats.org/officeDocument/2006/relationships">
+<p:sld xmlns:a="http://schemas.openxmlformats.org/drawingml/2006/main" xmlns:r="http://schemas.openxmlformats.org/officeDocument/2006/relationships" xmlns:p="http://schemas.openxmlformats.org/presentationml/2006/main">
   <p:cSld>
     <p:spTree>
       <p:nvGrpSpPr>
@@ -14250,7 +14255,14 @@
         <p:cNvGrpSpPr/>
         <p:nvPr/>
       </p:nvGrpSpPr>
-      <p:grpSpPr/>
+      <p:grpSpPr>
+        <a:xfrm>
+          <a:off x="0" y="0"/>
+          <a:ext cx="0" cy="0"/>
+          <a:chOff x="0" y="0"/>
+          <a:chExt cx="0" cy="0"/>
+        </a:xfrm>
+      </p:grpSpPr>
       <p:sp>
         <p:nvSpPr>
           <p:cNvPr id="2" name="Rectangle 1"/>
@@ -14291,6 +14303,7 @@
           <a:lstStyle/>
           <a:p>
             <a:pPr algn="ctr"/>
+            <a:endParaRPr/>
           </a:p>
         </p:txBody>
       </p:sp>

</xml_diff>